<commit_message>
Transferencia bancaria · Chile
</commit_message>
<xml_diff>
--- a/A1_Nivel_1/05_Fechas_Numeros/Sesion_05_Fechas_Numeros.pptx
+++ b/A1_Nivel_1/05_Fechas_Numeros/Sesion_05_Fechas_Numeros.pptx
@@ -4,6 +4,9 @@
   <p:sldMasterIdLst>
     <p:sldMasterId id="2147483648" r:id="rId1"/>
   </p:sldMasterIdLst>
+  <p:notesMasterIdLst>
+    <p:notesMasterId r:id="rId16"/>
+  </p:notesMasterIdLst>
   <p:sldIdLst>
     <p:sldId id="256" r:id="rId2"/>
     <p:sldId id="257" r:id="rId3"/>
@@ -20,9 +23,6 @@
     <p:sldId id="268" r:id="rId14"/>
     <p:sldId id="269" r:id="rId15"/>
   </p:sldIdLst>
-  <p:notesMasterIdLst>
-    <p:notesMasterId r:id="rId16"/>
-  </p:notesMasterIdLst>
   <p:sldSz cx="12192000" cy="6858000"/>
   <p:notesSz cx="6858000" cy="12192000"/>
   <p:defaultTextStyle>
@@ -117,6 +117,11 @@
       </a:defRPr>
     </a:lvl9pPr>
   </p:defaultTextStyle>
+  <p:extLst>
+    <p:ext uri="{EFAFB233-063F-42B5-8137-9DF3F51BA10A}">
+      <p15:sldGuideLst xmlns:p15="http://schemas.microsoft.com/office/powerpoint/2012/main"/>
+    </p:ext>
+  </p:extLst>
 </p:presentation>
 </file>
 
@@ -142,234 +147,10 @@
           <a:chExt cx="0" cy="0"/>
         </a:xfrm>
       </p:grpSpPr>
-      <p:sp>
-        <p:nvSpPr>
-          <p:cNvPr id="2" name="Header Placeholder 1"/>
-          <p:cNvSpPr>
-            <a:spLocks noGrp="1"/>
-          </p:cNvSpPr>
-          <p:nvPr>
-            <p:ph type="hdr" sz="quarter"/>
-          </p:nvPr>
-        </p:nvSpPr>
-        <p:spPr>
-          <a:xfrm>
-            <a:off x="0" y="0"/>
-            <a:ext cx="2971800" cy="458788"/>
-          </a:xfrm>
-          <a:prstGeom prst="rect">
-            <a:avLst/>
-          </a:prstGeom>
-        </p:spPr>
-        <p:txBody>
-          <a:bodyPr vert="horz" lIns="91440" tIns="45720" rIns="91440" bIns="45720" rtlCol="0"/>
-          <a:lstStyle>
-            <a:lvl1pPr algn="l">
-              <a:defRPr sz="1200"/>
-            </a:lvl1pPr>
-          </a:lstStyle>
-          <a:p>
-            <a:endParaRPr lang="en-US"/>
-          </a:p>
-        </p:txBody>
-      </p:sp>
-      <p:sp>
-        <p:nvSpPr>
-          <p:cNvPr id="3" name="Date Placeholder 2"/>
-          <p:cNvSpPr>
-            <a:spLocks noGrp="1"/>
-          </p:cNvSpPr>
-          <p:nvPr>
-            <p:ph type="dt" idx="1"/>
-          </p:nvPr>
-        </p:nvSpPr>
-        <p:spPr>
-          <a:xfrm>
-            <a:off x="3884613" y="0"/>
-            <a:ext cx="2971800" cy="458788"/>
-          </a:xfrm>
-          <a:prstGeom prst="rect">
-            <a:avLst/>
-          </a:prstGeom>
-        </p:spPr>
-        <p:txBody>
-          <a:bodyPr vert="horz" lIns="91440" tIns="45720" rIns="91440" bIns="45720" rtlCol="0"/>
-          <a:lstStyle>
-            <a:lvl1pPr algn="r">
-              <a:defRPr sz="1200"/>
-            </a:lvl1pPr>
-          </a:lstStyle>
-          <a:p>
-            <a:fld id="{5282F153-3F37-0F45-9E97-73ACFA13230C}" type="datetimeFigureOut">
-              <a:rPr lang="en-US"/>
-              <a:t>7/23/19</a:t>
-            </a:fld>
-            <a:endParaRPr lang="en-US"/>
-          </a:p>
-        </p:txBody>
-      </p:sp>
-      <p:sp>
-        <p:nvSpPr>
-          <p:cNvPr id="4" name="Slide Image Placeholder 3"/>
-          <p:cNvSpPr>
-            <a:spLocks noGrp="1" noRot="1" noChangeAspect="1"/>
-          </p:cNvSpPr>
-          <p:nvPr>
-            <p:ph type="sldImg" idx="2"/>
-          </p:nvPr>
-        </p:nvSpPr>
-        <p:spPr>
-          <a:xfrm>
-            <a:off x="685800" y="1143000"/>
-            <a:ext cx="5486400" cy="3086100"/>
-          </a:xfrm>
-          <a:prstGeom prst="rect">
-            <a:avLst/>
-          </a:prstGeom>
-          <a:noFill/>
-          <a:ln w="12700">
-            <a:solidFill>
-              <a:prstClr val="black"/>
-            </a:solidFill>
-          </a:ln>
-        </p:spPr>
-        <p:txBody>
-          <a:bodyPr vert="horz" lIns="91440" tIns="45720" rIns="91440" bIns="45720" rtlCol="0" anchor="ctr"/>
-          <a:lstStyle/>
-          <a:p>
-            <a:endParaRPr lang="en-US"/>
-          </a:p>
-        </p:txBody>
-      </p:sp>
-      <p:sp>
-        <p:nvSpPr>
-          <p:cNvPr id="5" name="Notes Placeholder 4"/>
-          <p:cNvSpPr>
-            <a:spLocks noGrp="1"/>
-          </p:cNvSpPr>
-          <p:nvPr>
-            <p:ph type="body" sz="quarter" idx="3"/>
-          </p:nvPr>
-        </p:nvSpPr>
-        <p:spPr>
-          <a:xfrm>
-            <a:off x="685800" y="4400550"/>
-            <a:ext cx="5486400" cy="3600450"/>
-          </a:xfrm>
-          <a:prstGeom prst="rect">
-            <a:avLst/>
-          </a:prstGeom>
-        </p:spPr>
-        <p:txBody>
-          <a:bodyPr vert="horz" lIns="91440" tIns="45720" rIns="91440" bIns="45720" rtlCol="0"/>
-          <a:lstStyle/>
-          <a:p>
-            <a:pPr lvl="0"/>
-            <a:r>
-              <a:rPr lang="en-US"/>
-              <a:t>Click to edit Master text styles</a:t>
-            </a:r>
-          </a:p>
-          <a:p>
-            <a:pPr lvl="1"/>
-            <a:r>
-              <a:rPr lang="en-US"/>
-              <a:t>Second level</a:t>
-            </a:r>
-          </a:p>
-          <a:p>
-            <a:pPr lvl="2"/>
-            <a:r>
-              <a:rPr lang="en-US"/>
-              <a:t>Third level</a:t>
-            </a:r>
-          </a:p>
-          <a:p>
-            <a:pPr lvl="3"/>
-            <a:r>
-              <a:rPr lang="en-US"/>
-              <a:t>Fourth level</a:t>
-            </a:r>
-          </a:p>
-          <a:p>
-            <a:pPr lvl="4"/>
-            <a:r>
-              <a:rPr lang="en-US"/>
-              <a:t>Fifth level</a:t>
-            </a:r>
-          </a:p>
-        </p:txBody>
-      </p:sp>
-      <p:sp>
-        <p:nvSpPr>
-          <p:cNvPr id="6" name="Footer Placeholder 5"/>
-          <p:cNvSpPr>
-            <a:spLocks noGrp="1"/>
-          </p:cNvSpPr>
-          <p:nvPr>
-            <p:ph type="ftr" sz="quarter" idx="4"/>
-          </p:nvPr>
-        </p:nvSpPr>
-        <p:spPr>
-          <a:xfrm>
-            <a:off x="0" y="8685213"/>
-            <a:ext cx="2971800" cy="458787"/>
-          </a:xfrm>
-          <a:prstGeom prst="rect">
-            <a:avLst/>
-          </a:prstGeom>
-        </p:spPr>
-        <p:txBody>
-          <a:bodyPr vert="horz" lIns="91440" tIns="45720" rIns="91440" bIns="45720" rtlCol="0" anchor="b"/>
-          <a:lstStyle>
-            <a:lvl1pPr algn="l">
-              <a:defRPr sz="1200"/>
-            </a:lvl1pPr>
-          </a:lstStyle>
-          <a:p>
-            <a:endParaRPr lang="en-US"/>
-          </a:p>
-        </p:txBody>
-      </p:sp>
-      <p:sp>
-        <p:nvSpPr>
-          <p:cNvPr id="7" name="Slide Number Placeholder 6"/>
-          <p:cNvSpPr>
-            <a:spLocks noGrp="1"/>
-          </p:cNvSpPr>
-          <p:nvPr>
-            <p:ph type="sldNum" sz="quarter" idx="5"/>
-          </p:nvPr>
-        </p:nvSpPr>
-        <p:spPr>
-          <a:xfrm>
-            <a:off x="3884613" y="8685213"/>
-            <a:ext cx="2971800" cy="458787"/>
-          </a:xfrm>
-          <a:prstGeom prst="rect">
-            <a:avLst/>
-          </a:prstGeom>
-        </p:spPr>
-        <p:txBody>
-          <a:bodyPr vert="horz" lIns="91440" tIns="45720" rIns="91440" bIns="45720" rtlCol="0" anchor="b"/>
-          <a:lstStyle>
-            <a:lvl1pPr algn="r">
-              <a:defRPr sz="1200"/>
-            </a:lvl1pPr>
-          </a:lstStyle>
-          <a:p>
-            <a:fld id="{CE5E9CC1-C706-0F49-92D6-E571CC5EEA8F}" type="slidenum">
-              <a:rPr lang="en-US"/>
-              <a:t>‹#›</a:t>
-            </a:fld>
-            <a:endParaRPr lang="en-US"/>
-          </a:p>
-        </p:txBody>
-      </p:sp>
     </p:spTree>
     <p:extLst>
       <p:ext uri="{BB962C8B-B14F-4D97-AF65-F5344CB8AC3E}">
-        <p14:creationId xmlns:p14="http://schemas.microsoft.com/office/powerpoint/2010/main" val="1024086991"/>
+        <p14:creationId xmlns:p14="http://schemas.microsoft.com/office/powerpoint/2010/main" val="1594721349"/>
       </p:ext>
     </p:extLst>
   </p:cSld>
@@ -513,10 +294,6 @@
           <a:bodyPr/>
           <a:lstStyle/>
           <a:p>
-            <a:r>
-              <a:rPr lang="en-US" dirty="0"/>
-              <a:t/>
-            </a:r>
             <a:endParaRPr lang="en-US" dirty="0"/>
           </a:p>
         </p:txBody>
@@ -601,10 +378,6 @@
           <a:bodyPr/>
           <a:lstStyle/>
           <a:p>
-            <a:r>
-              <a:rPr lang="en-US" dirty="0"/>
-              <a:t/>
-            </a:r>
             <a:endParaRPr lang="en-US" dirty="0"/>
           </a:p>
         </p:txBody>
@@ -689,10 +462,6 @@
           <a:bodyPr/>
           <a:lstStyle/>
           <a:p>
-            <a:r>
-              <a:rPr lang="en-US" dirty="0"/>
-              <a:t/>
-            </a:r>
             <a:endParaRPr lang="en-US" dirty="0"/>
           </a:p>
         </p:txBody>
@@ -777,10 +546,6 @@
           <a:bodyPr/>
           <a:lstStyle/>
           <a:p>
-            <a:r>
-              <a:rPr lang="en-US" dirty="0"/>
-              <a:t/>
-            </a:r>
             <a:endParaRPr lang="en-US" dirty="0"/>
           </a:p>
         </p:txBody>
@@ -865,10 +630,6 @@
           <a:bodyPr/>
           <a:lstStyle/>
           <a:p>
-            <a:r>
-              <a:rPr lang="en-US" dirty="0"/>
-              <a:t/>
-            </a:r>
             <a:endParaRPr lang="en-US" dirty="0"/>
           </a:p>
         </p:txBody>
@@ -953,10 +714,6 @@
           <a:bodyPr/>
           <a:lstStyle/>
           <a:p>
-            <a:r>
-              <a:rPr lang="en-US" dirty="0"/>
-              <a:t/>
-            </a:r>
             <a:endParaRPr lang="en-US" dirty="0"/>
           </a:p>
         </p:txBody>
@@ -1041,10 +798,6 @@
           <a:bodyPr/>
           <a:lstStyle/>
           <a:p>
-            <a:r>
-              <a:rPr lang="en-US" dirty="0"/>
-              <a:t/>
-            </a:r>
             <a:endParaRPr lang="en-US" dirty="0"/>
           </a:p>
         </p:txBody>
@@ -1129,10 +882,6 @@
           <a:bodyPr/>
           <a:lstStyle/>
           <a:p>
-            <a:r>
-              <a:rPr lang="en-US" dirty="0"/>
-              <a:t/>
-            </a:r>
             <a:endParaRPr lang="en-US" dirty="0"/>
           </a:p>
         </p:txBody>
@@ -1217,10 +966,6 @@
           <a:bodyPr/>
           <a:lstStyle/>
           <a:p>
-            <a:r>
-              <a:rPr lang="en-US" dirty="0"/>
-              <a:t/>
-            </a:r>
             <a:endParaRPr lang="en-US" dirty="0"/>
           </a:p>
         </p:txBody>
@@ -1305,10 +1050,6 @@
           <a:bodyPr/>
           <a:lstStyle/>
           <a:p>
-            <a:r>
-              <a:rPr lang="en-US" dirty="0"/>
-              <a:t/>
-            </a:r>
             <a:endParaRPr lang="en-US" dirty="0"/>
           </a:p>
         </p:txBody>
@@ -1393,10 +1134,6 @@
           <a:bodyPr/>
           <a:lstStyle/>
           <a:p>
-            <a:r>
-              <a:rPr lang="en-US" dirty="0"/>
-              <a:t/>
-            </a:r>
             <a:endParaRPr lang="en-US" dirty="0"/>
           </a:p>
         </p:txBody>
@@ -1481,10 +1218,6 @@
           <a:bodyPr/>
           <a:lstStyle/>
           <a:p>
-            <a:r>
-              <a:rPr lang="en-US" dirty="0"/>
-              <a:t/>
-            </a:r>
             <a:endParaRPr lang="en-US" dirty="0"/>
           </a:p>
         </p:txBody>
@@ -1569,10 +1302,6 @@
           <a:bodyPr/>
           <a:lstStyle/>
           <a:p>
-            <a:r>
-              <a:rPr lang="en-US" dirty="0"/>
-              <a:t/>
-            </a:r>
             <a:endParaRPr lang="en-US" dirty="0"/>
           </a:p>
         </p:txBody>
@@ -1657,10 +1386,6 @@
           <a:bodyPr/>
           <a:lstStyle/>
           <a:p>
-            <a:r>
-              <a:rPr lang="en-US" dirty="0"/>
-              <a:t/>
-            </a:r>
             <a:endParaRPr lang="en-US" dirty="0"/>
           </a:p>
         </p:txBody>
@@ -1734,6 +1459,11 @@
 <file path=ppt/slideMasters/slideMaster1.xml><?xml version="1.0" encoding="utf-8"?>
 <p:sldMaster xmlns:a="http://schemas.openxmlformats.org/drawingml/2006/main" xmlns:r="http://schemas.openxmlformats.org/officeDocument/2006/relationships" xmlns:p="http://schemas.openxmlformats.org/presentationml/2006/main">
   <p:cSld>
+    <p:bg>
+      <p:bgRef idx="1001">
+        <a:schemeClr val="bg1"/>
+      </p:bgRef>
+    </p:bg>
     <p:spTree>
       <p:nvGrpSpPr>
         <p:cNvPr id="1" name=""/>
@@ -2016,6 +1746,7 @@
         <a:solidFill>
           <a:srgbClr val="3D2EE8"/>
         </a:solidFill>
+        <a:effectLst/>
       </p:bgPr>
     </p:bg>
     <p:spTree>
@@ -2034,14 +1765,14 @@
       </p:grpSpPr>
       <p:pic>
         <p:nvPicPr>
-          <p:cNvPr id="2" name="Image 0" descr="/sessions/sleepy-zen-cray/mnt/outputs/deck_assets/logo_principal_blanco.png">    </p:cNvPr>
+          <p:cNvPr id="2" name="Image 0" descr="/sessions/sleepy-zen-cray/mnt/outputs/deck_assets/logo_principal_blanco.png"/>
           <p:cNvPicPr>
             <a:picLocks noChangeAspect="1"/>
           </p:cNvPicPr>
           <p:nvPr/>
         </p:nvPicPr>
         <p:blipFill>
-          <a:blip r:embed="rId1"/>
+          <a:blip r:embed="rId3"/>
           <a:stretch>
             <a:fillRect/>
           </a:stretch>
@@ -2077,11 +1808,11 @@
           <a:bodyPr wrap="square" rtlCol="0" anchor="ctr"/>
           <a:lstStyle/>
           <a:p>
-            <a:pPr algn="ctr" indent="0" marL="0">
-              <a:buNone/>
-            </a:pPr>
-            <a:r>
-              <a:rPr lang="en-US" sz="1400" spc="800" kern="0" dirty="0">
+            <a:pPr marL="0" indent="0" algn="ctr">
+              <a:buNone/>
+            </a:pPr>
+            <a:r>
+              <a:rPr lang="en-US" sz="1400" kern="0" spc="800" dirty="0">
                 <a:solidFill>
                   <a:srgbClr val="FFFFFF"/>
                 </a:solidFill>
@@ -2116,7 +1847,7 @@
           <a:bodyPr wrap="square" rtlCol="0" anchor="ctr"/>
           <a:lstStyle/>
           <a:p>
-            <a:pPr algn="ctr" indent="0" marL="0">
+            <a:pPr marL="0" indent="0" algn="ctr">
               <a:buNone/>
             </a:pPr>
             <a:r>
@@ -2155,7 +1886,7 @@
           <a:bodyPr wrap="square" rtlCol="0" anchor="ctr"/>
           <a:lstStyle/>
           <a:p>
-            <a:pPr algn="ctr" indent="0" marL="0">
+            <a:pPr marL="0" indent="0" algn="ctr">
               <a:buNone/>
             </a:pPr>
             <a:r>
@@ -2194,7 +1925,7 @@
           <a:bodyPr wrap="square" rtlCol="0" anchor="ctr"/>
           <a:lstStyle/>
           <a:p>
-            <a:pPr algn="ctr" indent="0" marL="0">
+            <a:pPr marL="0" indent="0" algn="ctr">
               <a:buNone/>
             </a:pPr>
             <a:r>
@@ -2214,14 +1945,14 @@
       </p:sp>
       <p:pic>
         <p:nvPicPr>
-          <p:cNvPr id="7" name="Image 1" descr="/sessions/sleepy-zen-cray/mnt/outputs/deck_assets/sello_linea_v1_05.png">    </p:cNvPr>
+          <p:cNvPr id="7" name="Image 1" descr="/sessions/sleepy-zen-cray/mnt/outputs/deck_assets/sello_linea_v1_05.png"/>
           <p:cNvPicPr>
             <a:picLocks noChangeAspect="1"/>
           </p:cNvPicPr>
           <p:nvPr/>
         </p:nvPicPr>
         <p:blipFill>
-          <a:blip r:embed="rId2"/>
+          <a:blip r:embed="rId4"/>
           <a:stretch>
             <a:fillRect/>
           </a:stretch>
@@ -2257,11 +1988,11 @@
           <a:bodyPr wrap="square" rtlCol="0" anchor="ctr"/>
           <a:lstStyle/>
           <a:p>
-            <a:pPr algn="ctr" indent="0" marL="0">
-              <a:buNone/>
-            </a:pPr>
-            <a:r>
-              <a:rPr lang="en-US" sz="1000" spc="400" kern="0" dirty="0">
+            <a:pPr marL="0" indent="0" algn="ctr">
+              <a:buNone/>
+            </a:pPr>
+            <a:r>
+              <a:rPr lang="en-US" sz="1000" kern="0" spc="400" dirty="0">
                 <a:solidFill>
                   <a:srgbClr val="FFFFFF"/>
                 </a:solidFill>
@@ -2291,6 +2022,7 @@
         <a:solidFill>
           <a:srgbClr val="FFFFFF"/>
         </a:solidFill>
+        <a:effectLst/>
       </p:bgPr>
     </p:bg>
     <p:spTree>
@@ -2328,11 +2060,11 @@
           <a:bodyPr wrap="square" rtlCol="0" anchor="ctr"/>
           <a:lstStyle/>
           <a:p>
-            <a:pPr indent="0" marL="0">
-              <a:buNone/>
-            </a:pPr>
-            <a:r>
-              <a:rPr lang="en-US" sz="900" b="1" spc="600" kern="0" dirty="0">
+            <a:pPr marL="0" indent="0">
+              <a:buNone/>
+            </a:pPr>
+            <a:r>
+              <a:rPr lang="en-US" sz="900" b="1" kern="0" spc="600" dirty="0">
                 <a:solidFill>
                   <a:srgbClr val="3D2EE8"/>
                 </a:solidFill>
@@ -2367,7 +2099,7 @@
           <a:bodyPr wrap="square" rtlCol="0" anchor="ctr"/>
           <a:lstStyle/>
           <a:p>
-            <a:pPr indent="0" marL="0">
+            <a:pPr marL="0" indent="0">
               <a:buNone/>
             </a:pPr>
             <a:r>
@@ -2406,7 +2138,7 @@
           <a:bodyPr wrap="square" rtlCol="0" anchor="t"/>
           <a:lstStyle/>
           <a:p>
-            <a:pPr indent="0" marL="0">
+            <a:pPr marL="0" indent="0">
               <a:lnSpc>
                 <a:spcPct val="140000"/>
               </a:lnSpc>
@@ -2426,7 +2158,7 @@
             <a:endParaRPr lang="en-US" sz="1400" dirty="0"/>
           </a:p>
           <a:p>
-            <a:pPr indent="0" marL="0">
+            <a:pPr marL="0" indent="0">
               <a:lnSpc>
                 <a:spcPct val="140000"/>
               </a:lnSpc>
@@ -2435,7 +2167,7 @@
             <a:endParaRPr lang="en-US" sz="1400" dirty="0"/>
           </a:p>
           <a:p>
-            <a:pPr indent="0" marL="0">
+            <a:pPr marL="0" indent="0">
               <a:lnSpc>
                 <a:spcPct val="140000"/>
               </a:lnSpc>
@@ -2455,7 +2187,7 @@
             <a:endParaRPr lang="en-US" sz="1400" dirty="0"/>
           </a:p>
           <a:p>
-            <a:pPr indent="0" marL="0">
+            <a:pPr marL="0" indent="0">
               <a:lnSpc>
                 <a:spcPct val="140000"/>
               </a:lnSpc>
@@ -2475,7 +2207,7 @@
             <a:endParaRPr lang="en-US" sz="1400" dirty="0"/>
           </a:p>
           <a:p>
-            <a:pPr indent="0" marL="0">
+            <a:pPr marL="0" indent="0">
               <a:lnSpc>
                 <a:spcPct val="140000"/>
               </a:lnSpc>
@@ -2484,7 +2216,7 @@
             <a:endParaRPr lang="en-US" sz="1400" dirty="0"/>
           </a:p>
           <a:p>
-            <a:pPr indent="0" marL="0">
+            <a:pPr marL="0" indent="0">
               <a:lnSpc>
                 <a:spcPct val="140000"/>
               </a:lnSpc>
@@ -2504,7 +2236,7 @@
             <a:endParaRPr lang="en-US" sz="1400" dirty="0"/>
           </a:p>
           <a:p>
-            <a:pPr indent="0" marL="0">
+            <a:pPr marL="0" indent="0">
               <a:lnSpc>
                 <a:spcPct val="140000"/>
               </a:lnSpc>
@@ -2524,7 +2256,7 @@
             <a:endParaRPr lang="en-US" sz="1400" dirty="0"/>
           </a:p>
           <a:p>
-            <a:pPr indent="0" marL="0">
+            <a:pPr marL="0" indent="0">
               <a:lnSpc>
                 <a:spcPct val="140000"/>
               </a:lnSpc>
@@ -2533,7 +2265,7 @@
             <a:endParaRPr lang="en-US" sz="1400" dirty="0"/>
           </a:p>
           <a:p>
-            <a:pPr indent="0" marL="0">
+            <a:pPr marL="0" indent="0">
               <a:lnSpc>
                 <a:spcPct val="140000"/>
               </a:lnSpc>
@@ -2553,7 +2285,7 @@
             <a:endParaRPr lang="en-US" sz="1400" dirty="0"/>
           </a:p>
           <a:p>
-            <a:pPr indent="0" marL="0">
+            <a:pPr marL="0" indent="0">
               <a:lnSpc>
                 <a:spcPct val="140000"/>
               </a:lnSpc>
@@ -2573,7 +2305,7 @@
             <a:endParaRPr lang="en-US" sz="1400" dirty="0"/>
           </a:p>
           <a:p>
-            <a:pPr indent="0" marL="0">
+            <a:pPr marL="0" indent="0">
               <a:lnSpc>
                 <a:spcPct val="140000"/>
               </a:lnSpc>
@@ -2582,7 +2314,7 @@
             <a:endParaRPr lang="en-US" sz="1400" dirty="0"/>
           </a:p>
           <a:p>
-            <a:pPr indent="0" marL="0">
+            <a:pPr marL="0" indent="0">
               <a:lnSpc>
                 <a:spcPct val="140000"/>
               </a:lnSpc>
@@ -2602,7 +2334,7 @@
             <a:endParaRPr lang="en-US" sz="1400" dirty="0"/>
           </a:p>
           <a:p>
-            <a:pPr indent="0" marL="0">
+            <a:pPr marL="0" indent="0">
               <a:lnSpc>
                 <a:spcPct val="140000"/>
               </a:lnSpc>
@@ -2622,7 +2354,7 @@
             <a:endParaRPr lang="en-US" sz="1400" dirty="0"/>
           </a:p>
           <a:p>
-            <a:pPr indent="0" marL="0">
+            <a:pPr marL="0" indent="0">
               <a:lnSpc>
                 <a:spcPct val="140000"/>
               </a:lnSpc>
@@ -2691,7 +2423,7 @@
           <a:bodyPr wrap="square" rtlCol="0" anchor="ctr"/>
           <a:lstStyle/>
           <a:p>
-            <a:pPr algn="ctr" indent="0" marL="0">
+            <a:pPr marL="0" indent="0" algn="ctr">
               <a:buNone/>
             </a:pPr>
             <a:r>
@@ -2730,7 +2462,7 @@
           <a:bodyPr wrap="square" rtlCol="0" anchor="ctr"/>
           <a:lstStyle/>
           <a:p>
-            <a:pPr algn="ctr" indent="0" marL="0">
+            <a:pPr marL="0" indent="0" algn="ctr">
               <a:buNone/>
             </a:pPr>
             <a:r>
@@ -2769,7 +2501,7 @@
           <a:bodyPr wrap="square" rtlCol="0" anchor="ctr"/>
           <a:lstStyle/>
           <a:p>
-            <a:pPr algn="ctr" indent="0" marL="0">
+            <a:pPr marL="0" indent="0" algn="ctr">
               <a:buNone/>
             </a:pPr>
             <a:r>
@@ -2789,14 +2521,14 @@
       </p:sp>
       <p:pic>
         <p:nvPicPr>
-          <p:cNvPr id="9" name="Image 0" descr="/sessions/sleepy-zen-cray/mnt/outputs/deck_assets/logo_var2_azul.png">    </p:cNvPr>
+          <p:cNvPr id="9" name="Image 0" descr="/sessions/sleepy-zen-cray/mnt/outputs/deck_assets/logo_var2_azul.png"/>
           <p:cNvPicPr>
             <a:picLocks noChangeAspect="1"/>
           </p:cNvPicPr>
           <p:nvPr/>
         </p:nvPicPr>
         <p:blipFill>
-          <a:blip r:embed="rId1"/>
+          <a:blip r:embed="rId3"/>
           <a:stretch>
             <a:fillRect/>
           </a:stretch>
@@ -2813,14 +2545,14 @@
       </p:pic>
       <p:pic>
         <p:nvPicPr>
-          <p:cNvPr id="10" name="Image 1" descr="/sessions/sleepy-zen-cray/mnt/outputs/deck_assets/sello_linea_v1_01.png">    </p:cNvPr>
+          <p:cNvPr id="10" name="Image 1" descr="/sessions/sleepy-zen-cray/mnt/outputs/deck_assets/sello_linea_v1_01.png"/>
           <p:cNvPicPr>
             <a:picLocks noChangeAspect="1"/>
           </p:cNvPicPr>
           <p:nvPr/>
         </p:nvPicPr>
         <p:blipFill>
-          <a:blip r:embed="rId2"/>
+          <a:blip r:embed="rId4"/>
           <a:stretch>
             <a:fillRect/>
           </a:stretch>
@@ -2856,7 +2588,7 @@
           <a:bodyPr wrap="square" rtlCol="0" anchor="ctr"/>
           <a:lstStyle/>
           <a:p>
-            <a:pPr indent="0" marL="0">
+            <a:pPr marL="0" indent="0">
               <a:buNone/>
             </a:pPr>
             <a:r>
@@ -2895,7 +2627,7 @@
           <a:bodyPr wrap="square" rtlCol="0" anchor="ctr"/>
           <a:lstStyle/>
           <a:p>
-            <a:pPr algn="r" indent="0" marL="0">
+            <a:pPr marL="0" indent="0" algn="r">
               <a:buNone/>
             </a:pPr>
             <a:r>
@@ -2929,6 +2661,7 @@
         <a:solidFill>
           <a:srgbClr val="FFFFFF"/>
         </a:solidFill>
+        <a:effectLst/>
       </p:bgPr>
     </p:bg>
     <p:spTree>
@@ -2966,11 +2699,11 @@
           <a:bodyPr wrap="square" rtlCol="0" anchor="ctr"/>
           <a:lstStyle/>
           <a:p>
-            <a:pPr indent="0" marL="0">
-              <a:buNone/>
-            </a:pPr>
-            <a:r>
-              <a:rPr lang="en-US" sz="900" b="1" spc="600" kern="0" dirty="0">
+            <a:pPr marL="0" indent="0">
+              <a:buNone/>
+            </a:pPr>
+            <a:r>
+              <a:rPr lang="en-US" sz="900" b="1" kern="0" spc="600" dirty="0">
                 <a:solidFill>
                   <a:srgbClr val="FF5C5C"/>
                 </a:solidFill>
@@ -3005,7 +2738,7 @@
           <a:bodyPr wrap="square" rtlCol="0" anchor="ctr"/>
           <a:lstStyle/>
           <a:p>
-            <a:pPr indent="0" marL="0">
+            <a:pPr marL="0" indent="0">
               <a:buNone/>
             </a:pPr>
             <a:r>
@@ -3071,7 +2804,7 @@
           <a:bodyPr wrap="square" rtlCol="0" anchor="ctr"/>
           <a:lstStyle/>
           <a:p>
-            <a:pPr algn="ctr" indent="0" marL="0">
+            <a:pPr marL="0" indent="0" algn="ctr">
               <a:buNone/>
             </a:pPr>
             <a:r>
@@ -3110,7 +2843,7 @@
           <a:bodyPr wrap="square" rtlCol="0" anchor="ctr"/>
           <a:lstStyle/>
           <a:p>
-            <a:pPr algn="ctr" indent="0" marL="0">
+            <a:pPr marL="0" indent="0" algn="ctr">
               <a:buNone/>
             </a:pPr>
             <a:r>
@@ -3176,7 +2909,7 @@
           <a:bodyPr wrap="square" rtlCol="0" anchor="ctr"/>
           <a:lstStyle/>
           <a:p>
-            <a:pPr algn="ctr" indent="0" marL="0">
+            <a:pPr marL="0" indent="0" algn="ctr">
               <a:buNone/>
             </a:pPr>
             <a:r>
@@ -3215,7 +2948,7 @@
           <a:bodyPr wrap="square" rtlCol="0" anchor="ctr"/>
           <a:lstStyle/>
           <a:p>
-            <a:pPr algn="ctr" indent="0" marL="0">
+            <a:pPr marL="0" indent="0" algn="ctr">
               <a:buNone/>
             </a:pPr>
             <a:r>
@@ -3281,7 +3014,7 @@
           <a:bodyPr wrap="square" rtlCol="0" anchor="ctr"/>
           <a:lstStyle/>
           <a:p>
-            <a:pPr algn="ctr" indent="0" marL="0">
+            <a:pPr marL="0" indent="0" algn="ctr">
               <a:buNone/>
             </a:pPr>
             <a:r>
@@ -3320,7 +3053,7 @@
           <a:bodyPr wrap="square" rtlCol="0" anchor="ctr"/>
           <a:lstStyle/>
           <a:p>
-            <a:pPr algn="ctr" indent="0" marL="0">
+            <a:pPr marL="0" indent="0" algn="ctr">
               <a:buNone/>
             </a:pPr>
             <a:r>
@@ -3386,7 +3119,7 @@
           <a:bodyPr wrap="square" rtlCol="0" anchor="ctr"/>
           <a:lstStyle/>
           <a:p>
-            <a:pPr algn="ctr" indent="0" marL="0">
+            <a:pPr marL="0" indent="0" algn="ctr">
               <a:buNone/>
             </a:pPr>
             <a:r>
@@ -3425,7 +3158,7 @@
           <a:bodyPr wrap="square" rtlCol="0" anchor="ctr"/>
           <a:lstStyle/>
           <a:p>
-            <a:pPr algn="ctr" indent="0" marL="0">
+            <a:pPr marL="0" indent="0" algn="ctr">
               <a:buNone/>
             </a:pPr>
             <a:r>
@@ -3491,7 +3224,7 @@
           <a:bodyPr wrap="square" rtlCol="0" anchor="ctr"/>
           <a:lstStyle/>
           <a:p>
-            <a:pPr algn="ctr" indent="0" marL="0">
+            <a:pPr marL="0" indent="0" algn="ctr">
               <a:buNone/>
             </a:pPr>
             <a:r>
@@ -3530,7 +3263,7 @@
           <a:bodyPr wrap="square" rtlCol="0" anchor="ctr"/>
           <a:lstStyle/>
           <a:p>
-            <a:pPr algn="ctr" indent="0" marL="0">
+            <a:pPr marL="0" indent="0" algn="ctr">
               <a:buNone/>
             </a:pPr>
             <a:r>
@@ -3596,7 +3329,7 @@
           <a:bodyPr wrap="square" rtlCol="0" anchor="ctr"/>
           <a:lstStyle/>
           <a:p>
-            <a:pPr algn="ctr" indent="0" marL="0">
+            <a:pPr marL="0" indent="0" algn="ctr">
               <a:buNone/>
             </a:pPr>
             <a:r>
@@ -3635,7 +3368,7 @@
           <a:bodyPr wrap="square" rtlCol="0" anchor="ctr"/>
           <a:lstStyle/>
           <a:p>
-            <a:pPr algn="ctr" indent="0" marL="0">
+            <a:pPr marL="0" indent="0" algn="ctr">
               <a:buNone/>
             </a:pPr>
             <a:r>
@@ -3655,14 +3388,14 @@
       </p:sp>
       <p:pic>
         <p:nvPicPr>
-          <p:cNvPr id="22" name="Image 0" descr="/sessions/sleepy-zen-cray/mnt/outputs/deck_assets/logo_var2_azul.png">    </p:cNvPr>
+          <p:cNvPr id="22" name="Image 0" descr="/sessions/sleepy-zen-cray/mnt/outputs/deck_assets/logo_var2_azul.png"/>
           <p:cNvPicPr>
             <a:picLocks noChangeAspect="1"/>
           </p:cNvPicPr>
           <p:nvPr/>
         </p:nvPicPr>
         <p:blipFill>
-          <a:blip r:embed="rId1"/>
+          <a:blip r:embed="rId3"/>
           <a:stretch>
             <a:fillRect/>
           </a:stretch>
@@ -3679,14 +3412,14 @@
       </p:pic>
       <p:pic>
         <p:nvPicPr>
-          <p:cNvPr id="23" name="Image 1" descr="/sessions/sleepy-zen-cray/mnt/outputs/deck_assets/sello_linea_v1_01.png">    </p:cNvPr>
+          <p:cNvPr id="23" name="Image 1" descr="/sessions/sleepy-zen-cray/mnt/outputs/deck_assets/sello_linea_v1_01.png"/>
           <p:cNvPicPr>
             <a:picLocks noChangeAspect="1"/>
           </p:cNvPicPr>
           <p:nvPr/>
         </p:nvPicPr>
         <p:blipFill>
-          <a:blip r:embed="rId2"/>
+          <a:blip r:embed="rId4"/>
           <a:stretch>
             <a:fillRect/>
           </a:stretch>
@@ -3722,7 +3455,7 @@
           <a:bodyPr wrap="square" rtlCol="0" anchor="ctr"/>
           <a:lstStyle/>
           <a:p>
-            <a:pPr indent="0" marL="0">
+            <a:pPr marL="0" indent="0">
               <a:buNone/>
             </a:pPr>
             <a:r>
@@ -3761,7 +3494,7 @@
           <a:bodyPr wrap="square" rtlCol="0" anchor="ctr"/>
           <a:lstStyle/>
           <a:p>
-            <a:pPr algn="r" indent="0" marL="0">
+            <a:pPr marL="0" indent="0" algn="r">
               <a:buNone/>
             </a:pPr>
             <a:r>
@@ -3795,6 +3528,7 @@
         <a:solidFill>
           <a:srgbClr val="FFFFFF"/>
         </a:solidFill>
+        <a:effectLst/>
       </p:bgPr>
     </p:bg>
     <p:spTree>
@@ -3832,11 +3566,11 @@
           <a:bodyPr wrap="square" rtlCol="0" anchor="ctr"/>
           <a:lstStyle/>
           <a:p>
-            <a:pPr indent="0" marL="0">
-              <a:buNone/>
-            </a:pPr>
-            <a:r>
-              <a:rPr lang="en-US" sz="900" b="1" spc="600" kern="0" dirty="0">
+            <a:pPr marL="0" indent="0">
+              <a:buNone/>
+            </a:pPr>
+            <a:r>
+              <a:rPr lang="en-US" sz="900" b="1" kern="0" spc="600" dirty="0">
                 <a:solidFill>
                   <a:srgbClr val="3D2EE8"/>
                 </a:solidFill>
@@ -3871,7 +3605,7 @@
           <a:bodyPr wrap="square" rtlCol="0" anchor="ctr"/>
           <a:lstStyle/>
           <a:p>
-            <a:pPr indent="0" marL="0">
+            <a:pPr marL="0" indent="0">
               <a:buNone/>
             </a:pPr>
             <a:r>
@@ -3937,7 +3671,7 @@
           <a:bodyPr wrap="square" rtlCol="0" anchor="ctr"/>
           <a:lstStyle/>
           <a:p>
-            <a:pPr indent="0" marL="0">
+            <a:pPr marL="0" indent="0">
               <a:buNone/>
             </a:pPr>
             <a:r>
@@ -3976,7 +3710,7 @@
           <a:bodyPr wrap="square" rtlCol="0" anchor="ctr"/>
           <a:lstStyle/>
           <a:p>
-            <a:pPr indent="0" marL="0">
+            <a:pPr marL="0" indent="0">
               <a:buNone/>
             </a:pPr>
             <a:r>
@@ -4015,7 +3749,7 @@
           <a:bodyPr wrap="square" rtlCol="0" anchor="ctr"/>
           <a:lstStyle/>
           <a:p>
-            <a:pPr indent="0" marL="0">
+            <a:pPr marL="0" indent="0">
               <a:buNone/>
             </a:pPr>
             <a:r>
@@ -4054,7 +3788,7 @@
           <a:bodyPr wrap="square" rtlCol="0" anchor="ctr"/>
           <a:lstStyle/>
           <a:p>
-            <a:pPr indent="0" marL="0">
+            <a:pPr marL="0" indent="0">
               <a:buNone/>
             </a:pPr>
             <a:r>
@@ -4093,7 +3827,7 @@
           <a:bodyPr wrap="square" rtlCol="0" anchor="ctr"/>
           <a:lstStyle/>
           <a:p>
-            <a:pPr indent="0" marL="0">
+            <a:pPr marL="0" indent="0">
               <a:buNone/>
             </a:pPr>
             <a:r>
@@ -4132,7 +3866,7 @@
           <a:bodyPr wrap="square" rtlCol="0" anchor="ctr"/>
           <a:lstStyle/>
           <a:p>
-            <a:pPr indent="0" marL="0">
+            <a:pPr marL="0" indent="0">
               <a:buNone/>
             </a:pPr>
             <a:r>
@@ -4171,7 +3905,7 @@
           <a:bodyPr wrap="square" rtlCol="0" anchor="ctr"/>
           <a:lstStyle/>
           <a:p>
-            <a:pPr indent="0" marL="0">
+            <a:pPr marL="0" indent="0">
               <a:buNone/>
             </a:pPr>
             <a:r>
@@ -4210,7 +3944,7 @@
           <a:bodyPr wrap="square" rtlCol="0" anchor="ctr"/>
           <a:lstStyle/>
           <a:p>
-            <a:pPr indent="0" marL="0">
+            <a:pPr marL="0" indent="0">
               <a:buNone/>
             </a:pPr>
             <a:r>
@@ -4249,7 +3983,7 @@
           <a:bodyPr wrap="square" rtlCol="0" anchor="ctr"/>
           <a:lstStyle/>
           <a:p>
-            <a:pPr indent="0" marL="0">
+            <a:pPr marL="0" indent="0">
               <a:buNone/>
             </a:pPr>
             <a:r>
@@ -4288,7 +4022,7 @@
           <a:bodyPr wrap="square" rtlCol="0" anchor="ctr"/>
           <a:lstStyle/>
           <a:p>
-            <a:pPr indent="0" marL="0">
+            <a:pPr marL="0" indent="0">
               <a:buNone/>
             </a:pPr>
             <a:r>
@@ -4327,7 +4061,7 @@
           <a:bodyPr wrap="square" rtlCol="0" anchor="ctr"/>
           <a:lstStyle/>
           <a:p>
-            <a:pPr indent="0" marL="0">
+            <a:pPr marL="0" indent="0">
               <a:buNone/>
             </a:pPr>
             <a:r>
@@ -4366,7 +4100,7 @@
           <a:bodyPr wrap="square" rtlCol="0" anchor="ctr"/>
           <a:lstStyle/>
           <a:p>
-            <a:pPr indent="0" marL="0">
+            <a:pPr marL="0" indent="0">
               <a:buNone/>
             </a:pPr>
             <a:r>
@@ -4405,7 +4139,7 @@
           <a:bodyPr wrap="square" rtlCol="0" anchor="ctr"/>
           <a:lstStyle/>
           <a:p>
-            <a:pPr indent="0" marL="0">
+            <a:pPr marL="0" indent="0">
               <a:buNone/>
             </a:pPr>
             <a:r>
@@ -4444,7 +4178,7 @@
           <a:bodyPr wrap="square" rtlCol="0" anchor="ctr"/>
           <a:lstStyle/>
           <a:p>
-            <a:pPr indent="0" marL="0">
+            <a:pPr marL="0" indent="0">
               <a:buNone/>
             </a:pPr>
             <a:r>
@@ -4483,7 +4217,7 @@
           <a:bodyPr wrap="square" rtlCol="0" anchor="ctr"/>
           <a:lstStyle/>
           <a:p>
-            <a:pPr indent="0" marL="0">
+            <a:pPr marL="0" indent="0">
               <a:buNone/>
             </a:pPr>
             <a:r>
@@ -4522,7 +4256,7 @@
           <a:bodyPr wrap="square" rtlCol="0" anchor="ctr"/>
           <a:lstStyle/>
           <a:p>
-            <a:pPr indent="0" marL="0">
+            <a:pPr marL="0" indent="0">
               <a:buNone/>
             </a:pPr>
             <a:r>
@@ -4561,7 +4295,7 @@
           <a:bodyPr wrap="square" rtlCol="0" anchor="ctr"/>
           <a:lstStyle/>
           <a:p>
-            <a:pPr indent="0" marL="0">
+            <a:pPr marL="0" indent="0">
               <a:buNone/>
             </a:pPr>
             <a:r>
@@ -4600,7 +4334,7 @@
           <a:bodyPr wrap="square" rtlCol="0" anchor="ctr"/>
           <a:lstStyle/>
           <a:p>
-            <a:pPr indent="0" marL="0">
+            <a:pPr marL="0" indent="0">
               <a:buNone/>
             </a:pPr>
             <a:r>
@@ -4620,14 +4354,14 @@
       </p:sp>
       <p:pic>
         <p:nvPicPr>
-          <p:cNvPr id="23" name="Image 0" descr="/sessions/sleepy-zen-cray/mnt/outputs/deck_assets/logo_var2_azul.png">    </p:cNvPr>
+          <p:cNvPr id="23" name="Image 0" descr="/sessions/sleepy-zen-cray/mnt/outputs/deck_assets/logo_var2_azul.png"/>
           <p:cNvPicPr>
             <a:picLocks noChangeAspect="1"/>
           </p:cNvPicPr>
           <p:nvPr/>
         </p:nvPicPr>
         <p:blipFill>
-          <a:blip r:embed="rId1"/>
+          <a:blip r:embed="rId3"/>
           <a:stretch>
             <a:fillRect/>
           </a:stretch>
@@ -4644,14 +4378,14 @@
       </p:pic>
       <p:pic>
         <p:nvPicPr>
-          <p:cNvPr id="24" name="Image 1" descr="/sessions/sleepy-zen-cray/mnt/outputs/deck_assets/sello_linea_v1_01.png">    </p:cNvPr>
+          <p:cNvPr id="24" name="Image 1" descr="/sessions/sleepy-zen-cray/mnt/outputs/deck_assets/sello_linea_v1_01.png"/>
           <p:cNvPicPr>
             <a:picLocks noChangeAspect="1"/>
           </p:cNvPicPr>
           <p:nvPr/>
         </p:nvPicPr>
         <p:blipFill>
-          <a:blip r:embed="rId2"/>
+          <a:blip r:embed="rId4"/>
           <a:stretch>
             <a:fillRect/>
           </a:stretch>
@@ -4687,7 +4421,7 @@
           <a:bodyPr wrap="square" rtlCol="0" anchor="ctr"/>
           <a:lstStyle/>
           <a:p>
-            <a:pPr indent="0" marL="0">
+            <a:pPr marL="0" indent="0">
               <a:buNone/>
             </a:pPr>
             <a:r>
@@ -4726,7 +4460,7 @@
           <a:bodyPr wrap="square" rtlCol="0" anchor="ctr"/>
           <a:lstStyle/>
           <a:p>
-            <a:pPr algn="r" indent="0" marL="0">
+            <a:pPr marL="0" indent="0" algn="r">
               <a:buNone/>
             </a:pPr>
             <a:r>
@@ -4760,6 +4494,7 @@
         <a:solidFill>
           <a:srgbClr val="FF5C5C"/>
         </a:solidFill>
+        <a:effectLst/>
       </p:bgPr>
     </p:bg>
     <p:spTree>
@@ -4778,14 +4513,14 @@
       </p:grpSpPr>
       <p:pic>
         <p:nvPicPr>
-          <p:cNvPr id="2" name="Image 0" descr="/sessions/sleepy-zen-cray/mnt/outputs/deck_assets/logo_principal_blanco.png">    </p:cNvPr>
+          <p:cNvPr id="2" name="Image 0" descr="/sessions/sleepy-zen-cray/mnt/outputs/deck_assets/logo_principal_blanco.png"/>
           <p:cNvPicPr>
             <a:picLocks noChangeAspect="1"/>
           </p:cNvPicPr>
           <p:nvPr/>
         </p:nvPicPr>
         <p:blipFill>
-          <a:blip r:embed="rId1"/>
+          <a:blip r:embed="rId3"/>
           <a:stretch>
             <a:fillRect/>
           </a:stretch>
@@ -4821,11 +4556,11 @@
           <a:bodyPr wrap="square" rtlCol="0" anchor="ctr"/>
           <a:lstStyle/>
           <a:p>
-            <a:pPr algn="ctr" indent="0" marL="0">
-              <a:buNone/>
-            </a:pPr>
-            <a:r>
-              <a:rPr lang="en-US" sz="1000" b="1" spc="800" kern="0" dirty="0">
+            <a:pPr marL="0" indent="0" algn="ctr">
+              <a:buNone/>
+            </a:pPr>
+            <a:r>
+              <a:rPr lang="en-US" sz="1000" b="1" kern="0" spc="800" dirty="0">
                 <a:solidFill>
                   <a:srgbClr val="FFFFFF"/>
                 </a:solidFill>
@@ -4860,7 +4595,7 @@
           <a:bodyPr wrap="square" rtlCol="0" anchor="ctr"/>
           <a:lstStyle/>
           <a:p>
-            <a:pPr algn="ctr" indent="0" marL="0">
+            <a:pPr marL="0" indent="0" algn="ctr">
               <a:buNone/>
             </a:pPr>
             <a:r>
@@ -4926,7 +4661,7 @@
           <a:bodyPr wrap="square" rtlCol="0" anchor="t"/>
           <a:lstStyle/>
           <a:p>
-            <a:pPr indent="0" marL="0">
+            <a:pPr marL="0" indent="0">
               <a:lnSpc>
                 <a:spcPct val="150000"/>
               </a:lnSpc>
@@ -4946,7 +4681,7 @@
             <a:endParaRPr lang="en-US" sz="1500" dirty="0"/>
           </a:p>
           <a:p>
-            <a:pPr indent="0" marL="0">
+            <a:pPr marL="0" indent="0">
               <a:lnSpc>
                 <a:spcPct val="150000"/>
               </a:lnSpc>
@@ -4966,7 +4701,7 @@
             <a:endParaRPr lang="en-US" sz="1500" dirty="0"/>
           </a:p>
           <a:p>
-            <a:pPr indent="0" marL="0">
+            <a:pPr marL="0" indent="0">
               <a:lnSpc>
                 <a:spcPct val="150000"/>
               </a:lnSpc>
@@ -4986,7 +4721,7 @@
             <a:endParaRPr lang="en-US" sz="1500" dirty="0"/>
           </a:p>
           <a:p>
-            <a:pPr indent="0" marL="0">
+            <a:pPr marL="0" indent="0">
               <a:lnSpc>
                 <a:spcPct val="150000"/>
               </a:lnSpc>
@@ -5006,7 +4741,7 @@
             <a:endParaRPr lang="en-US" sz="1500" dirty="0"/>
           </a:p>
           <a:p>
-            <a:pPr indent="0" marL="0">
+            <a:pPr marL="0" indent="0">
               <a:lnSpc>
                 <a:spcPct val="150000"/>
               </a:lnSpc>
@@ -5026,7 +4761,7 @@
             <a:endParaRPr lang="en-US" sz="1500" dirty="0"/>
           </a:p>
           <a:p>
-            <a:pPr indent="0" marL="0">
+            <a:pPr marL="0" indent="0">
               <a:lnSpc>
                 <a:spcPct val="150000"/>
               </a:lnSpc>
@@ -5068,11 +4803,11 @@
           <a:bodyPr wrap="square" rtlCol="0" anchor="ctr"/>
           <a:lstStyle/>
           <a:p>
-            <a:pPr algn="ctr" indent="0" marL="0">
-              <a:buNone/>
-            </a:pPr>
-            <a:r>
-              <a:rPr lang="en-US" sz="1200" b="1" spc="600" kern="0" dirty="0">
+            <a:pPr marL="0" indent="0" algn="ctr">
+              <a:buNone/>
+            </a:pPr>
+            <a:r>
+              <a:rPr lang="en-US" sz="1200" b="1" kern="0" spc="600" dirty="0">
                 <a:solidFill>
                   <a:srgbClr val="FFFFFF"/>
                 </a:solidFill>
@@ -5107,7 +4842,7 @@
           <a:bodyPr wrap="square" rtlCol="0" anchor="ctr"/>
           <a:lstStyle/>
           <a:p>
-            <a:pPr algn="ctr" indent="0" marL="0">
+            <a:pPr marL="0" indent="0" algn="ctr">
               <a:buNone/>
             </a:pPr>
             <a:r>
@@ -5141,6 +4876,7 @@
         <a:solidFill>
           <a:srgbClr val="3D2EE8"/>
         </a:solidFill>
+        <a:effectLst/>
       </p:bgPr>
     </p:bg>
     <p:spTree>
@@ -5178,7 +4914,7 @@
           <a:bodyPr wrap="square" rtlCol="0" anchor="ctr"/>
           <a:lstStyle/>
           <a:p>
-            <a:pPr algn="ctr" indent="0" marL="0">
+            <a:pPr marL="0" indent="0" algn="ctr">
               <a:buNone/>
             </a:pPr>
             <a:r>
@@ -5217,7 +4953,7 @@
           <a:bodyPr wrap="square" rtlCol="0" anchor="ctr"/>
           <a:lstStyle/>
           <a:p>
-            <a:pPr algn="ctr" indent="0" marL="0">
+            <a:pPr marL="0" indent="0" algn="ctr">
               <a:buNone/>
             </a:pPr>
             <a:r>
@@ -5237,14 +4973,14 @@
       </p:sp>
       <p:pic>
         <p:nvPicPr>
-          <p:cNvPr id="4" name="Image 0" descr="/sessions/sleepy-zen-cray/mnt/outputs/deck_assets/logo_principal_blanco.png">    </p:cNvPr>
+          <p:cNvPr id="4" name="Image 0" descr="/sessions/sleepy-zen-cray/mnt/outputs/deck_assets/logo_principal_blanco.png"/>
           <p:cNvPicPr>
             <a:picLocks noChangeAspect="1"/>
           </p:cNvPicPr>
           <p:nvPr/>
         </p:nvPicPr>
         <p:blipFill>
-          <a:blip r:embed="rId1"/>
+          <a:blip r:embed="rId3"/>
           <a:stretch>
             <a:fillRect/>
           </a:stretch>
@@ -5280,11 +5016,11 @@
           <a:bodyPr wrap="square" rtlCol="0" anchor="ctr"/>
           <a:lstStyle/>
           <a:p>
-            <a:pPr algn="ctr" indent="0" marL="0">
-              <a:buNone/>
-            </a:pPr>
-            <a:r>
-              <a:rPr lang="en-US" sz="1000" b="1" spc="600" kern="0" dirty="0">
+            <a:pPr marL="0" indent="0" algn="ctr">
+              <a:buNone/>
+            </a:pPr>
+            <a:r>
+              <a:rPr lang="en-US" sz="1000" b="1" kern="0" spc="600" dirty="0">
                 <a:solidFill>
                   <a:srgbClr val="FFFFFF"/>
                 </a:solidFill>
@@ -5314,6 +5050,7 @@
         <a:solidFill>
           <a:srgbClr val="FFFFFF"/>
         </a:solidFill>
+        <a:effectLst/>
       </p:bgPr>
     </p:bg>
     <p:spTree>
@@ -5351,11 +5088,11 @@
           <a:bodyPr wrap="square" rtlCol="0" anchor="ctr"/>
           <a:lstStyle/>
           <a:p>
-            <a:pPr indent="0" marL="0">
-              <a:buNone/>
-            </a:pPr>
-            <a:r>
-              <a:rPr lang="en-US" sz="900" b="1" spc="600" kern="0" dirty="0">
+            <a:pPr marL="0" indent="0">
+              <a:buNone/>
+            </a:pPr>
+            <a:r>
+              <a:rPr lang="en-US" sz="900" b="1" kern="0" spc="600" dirty="0">
                 <a:solidFill>
                   <a:srgbClr val="3D2EE8"/>
                 </a:solidFill>
@@ -5390,7 +5127,7 @@
           <a:bodyPr wrap="square" rtlCol="0" anchor="ctr"/>
           <a:lstStyle/>
           <a:p>
-            <a:pPr indent="0" marL="0">
+            <a:pPr marL="0" indent="0">
               <a:buNone/>
             </a:pPr>
             <a:r>
@@ -5429,7 +5166,7 @@
           <a:bodyPr wrap="square" rtlCol="0" anchor="t"/>
           <a:lstStyle/>
           <a:p>
-            <a:pPr indent="0" marL="0">
+            <a:pPr marL="0" indent="0">
               <a:lnSpc>
                 <a:spcPct val="140000"/>
               </a:lnSpc>
@@ -5449,7 +5186,7 @@
             <a:endParaRPr lang="en-US" sz="1600" dirty="0"/>
           </a:p>
           <a:p>
-            <a:pPr indent="0" marL="0">
+            <a:pPr marL="0" indent="0">
               <a:lnSpc>
                 <a:spcPct val="140000"/>
               </a:lnSpc>
@@ -5458,7 +5195,7 @@
             <a:endParaRPr lang="en-US" sz="1600" dirty="0"/>
           </a:p>
           <a:p>
-            <a:pPr indent="0" marL="0">
+            <a:pPr marL="0" indent="0">
               <a:lnSpc>
                 <a:spcPct val="140000"/>
               </a:lnSpc>
@@ -5478,7 +5215,7 @@
             <a:endParaRPr lang="en-US" sz="1600" dirty="0"/>
           </a:p>
           <a:p>
-            <a:pPr indent="0" marL="0">
+            <a:pPr marL="0" indent="0">
               <a:lnSpc>
                 <a:spcPct val="140000"/>
               </a:lnSpc>
@@ -5487,7 +5224,7 @@
             <a:endParaRPr lang="en-US" sz="1600" dirty="0"/>
           </a:p>
           <a:p>
-            <a:pPr indent="0" marL="0">
+            <a:pPr marL="0" indent="0">
               <a:lnSpc>
                 <a:spcPct val="140000"/>
               </a:lnSpc>
@@ -5510,14 +5247,14 @@
       </p:sp>
       <p:pic>
         <p:nvPicPr>
-          <p:cNvPr id="5" name="Image 0" descr="/sessions/sleepy-zen-cray/mnt/outputs/deck_assets/sello_relleno_v1_01.png">    </p:cNvPr>
+          <p:cNvPr id="5" name="Image 0" descr="/sessions/sleepy-zen-cray/mnt/outputs/deck_assets/sello_relleno_v1_01.png"/>
           <p:cNvPicPr>
             <a:picLocks noChangeAspect="1"/>
           </p:cNvPicPr>
           <p:nvPr/>
         </p:nvPicPr>
         <p:blipFill>
-          <a:blip r:embed="rId1"/>
+          <a:blip r:embed="rId3"/>
           <a:stretch>
             <a:fillRect/>
           </a:stretch>
@@ -5534,14 +5271,14 @@
       </p:pic>
       <p:pic>
         <p:nvPicPr>
-          <p:cNvPr id="6" name="Image 1" descr="/sessions/sleepy-zen-cray/mnt/outputs/deck_assets/sello_linea_v1_01.png">    </p:cNvPr>
+          <p:cNvPr id="6" name="Image 1" descr="/sessions/sleepy-zen-cray/mnt/outputs/deck_assets/sello_linea_v1_01.png"/>
           <p:cNvPicPr>
             <a:picLocks noChangeAspect="1"/>
           </p:cNvPicPr>
           <p:nvPr/>
         </p:nvPicPr>
         <p:blipFill>
-          <a:blip r:embed="rId2"/>
+          <a:blip r:embed="rId4"/>
           <a:stretch>
             <a:fillRect/>
           </a:stretch>
@@ -5577,7 +5314,7 @@
           <a:bodyPr wrap="square" rtlCol="0" anchor="ctr"/>
           <a:lstStyle/>
           <a:p>
-            <a:pPr indent="0" marL="0">
+            <a:pPr marL="0" indent="0">
               <a:buNone/>
             </a:pPr>
             <a:r>
@@ -5616,7 +5353,7 @@
           <a:bodyPr wrap="square" rtlCol="0" anchor="ctr"/>
           <a:lstStyle/>
           <a:p>
-            <a:pPr algn="r" indent="0" marL="0">
+            <a:pPr marL="0" indent="0" algn="r">
               <a:buNone/>
             </a:pPr>
             <a:r>
@@ -5650,6 +5387,7 @@
         <a:solidFill>
           <a:srgbClr val="FFFFFF"/>
         </a:solidFill>
+        <a:effectLst/>
       </p:bgPr>
     </p:bg>
     <p:spTree>
@@ -5687,11 +5425,11 @@
           <a:bodyPr wrap="square" rtlCol="0" anchor="ctr"/>
           <a:lstStyle/>
           <a:p>
-            <a:pPr indent="0" marL="0">
-              <a:buNone/>
-            </a:pPr>
-            <a:r>
-              <a:rPr lang="en-US" sz="900" b="1" spc="600" kern="0" dirty="0">
+            <a:pPr marL="0" indent="0">
+              <a:buNone/>
+            </a:pPr>
+            <a:r>
+              <a:rPr lang="en-US" sz="900" b="1" kern="0" spc="600" dirty="0">
                 <a:solidFill>
                   <a:srgbClr val="3D2EE8"/>
                 </a:solidFill>
@@ -5726,7 +5464,7 @@
           <a:bodyPr wrap="square" rtlCol="0" anchor="ctr"/>
           <a:lstStyle/>
           <a:p>
-            <a:pPr indent="0" marL="0">
+            <a:pPr marL="0" indent="0">
               <a:buNone/>
             </a:pPr>
             <a:r>
@@ -5765,7 +5503,7 @@
           <a:bodyPr wrap="square" rtlCol="0" anchor="t"/>
           <a:lstStyle/>
           <a:p>
-            <a:pPr indent="0" marL="0">
+            <a:pPr marL="0" indent="0">
               <a:lnSpc>
                 <a:spcPct val="140000"/>
               </a:lnSpc>
@@ -5785,7 +5523,7 @@
             <a:endParaRPr lang="en-US" sz="1400" dirty="0"/>
           </a:p>
           <a:p>
-            <a:pPr indent="0" marL="0">
+            <a:pPr marL="0" indent="0">
               <a:lnSpc>
                 <a:spcPct val="140000"/>
               </a:lnSpc>
@@ -5805,7 +5543,7 @@
             <a:endParaRPr lang="en-US" sz="1400" dirty="0"/>
           </a:p>
           <a:p>
-            <a:pPr indent="0" marL="0">
+            <a:pPr marL="0" indent="0">
               <a:lnSpc>
                 <a:spcPct val="140000"/>
               </a:lnSpc>
@@ -5825,7 +5563,7 @@
             <a:endParaRPr lang="en-US" sz="1400" dirty="0"/>
           </a:p>
           <a:p>
-            <a:pPr indent="0" marL="0">
+            <a:pPr marL="0" indent="0">
               <a:lnSpc>
                 <a:spcPct val="140000"/>
               </a:lnSpc>
@@ -5845,7 +5583,7 @@
             <a:endParaRPr lang="en-US" sz="1400" dirty="0"/>
           </a:p>
           <a:p>
-            <a:pPr indent="0" marL="0">
+            <a:pPr marL="0" indent="0">
               <a:lnSpc>
                 <a:spcPct val="140000"/>
               </a:lnSpc>
@@ -5865,7 +5603,7 @@
             <a:endParaRPr lang="en-US" sz="1400" dirty="0"/>
           </a:p>
           <a:p>
-            <a:pPr indent="0" marL="0">
+            <a:pPr marL="0" indent="0">
               <a:lnSpc>
                 <a:spcPct val="140000"/>
               </a:lnSpc>
@@ -5885,7 +5623,7 @@
             <a:endParaRPr lang="en-US" sz="1400" dirty="0"/>
           </a:p>
           <a:p>
-            <a:pPr indent="0" marL="0">
+            <a:pPr marL="0" indent="0">
               <a:lnSpc>
                 <a:spcPct val="140000"/>
               </a:lnSpc>
@@ -5894,7 +5632,7 @@
             <a:endParaRPr lang="en-US" sz="1400" dirty="0"/>
           </a:p>
           <a:p>
-            <a:pPr indent="0" marL="0">
+            <a:pPr marL="0" indent="0">
               <a:lnSpc>
                 <a:spcPct val="140000"/>
               </a:lnSpc>
@@ -5963,7 +5701,7 @@
           <a:bodyPr wrap="square" rtlCol="0" anchor="ctr"/>
           <a:lstStyle/>
           <a:p>
-            <a:pPr algn="ctr" indent="0" marL="0">
+            <a:pPr marL="0" indent="0" algn="ctr">
               <a:buNone/>
             </a:pPr>
             <a:r>
@@ -6002,7 +5740,7 @@
           <a:bodyPr wrap="square" rtlCol="0" anchor="ctr"/>
           <a:lstStyle/>
           <a:p>
-            <a:pPr algn="ctr" indent="0" marL="0">
+            <a:pPr marL="0" indent="0" algn="ctr">
               <a:buNone/>
             </a:pPr>
             <a:r>
@@ -6041,7 +5779,7 @@
           <a:bodyPr wrap="square" rtlCol="0" anchor="ctr"/>
           <a:lstStyle/>
           <a:p>
-            <a:pPr algn="ctr" indent="0" marL="0">
+            <a:pPr marL="0" indent="0" algn="ctr">
               <a:buNone/>
             </a:pPr>
             <a:r>
@@ -6061,14 +5799,14 @@
       </p:sp>
       <p:pic>
         <p:nvPicPr>
-          <p:cNvPr id="9" name="Image 0" descr="/sessions/sleepy-zen-cray/mnt/outputs/deck_assets/logo_var2_azul.png">    </p:cNvPr>
+          <p:cNvPr id="9" name="Image 0" descr="/sessions/sleepy-zen-cray/mnt/outputs/deck_assets/logo_var2_azul.png"/>
           <p:cNvPicPr>
             <a:picLocks noChangeAspect="1"/>
           </p:cNvPicPr>
           <p:nvPr/>
         </p:nvPicPr>
         <p:blipFill>
-          <a:blip r:embed="rId1"/>
+          <a:blip r:embed="rId3"/>
           <a:stretch>
             <a:fillRect/>
           </a:stretch>
@@ -6085,14 +5823,14 @@
       </p:pic>
       <p:pic>
         <p:nvPicPr>
-          <p:cNvPr id="10" name="Image 1" descr="/sessions/sleepy-zen-cray/mnt/outputs/deck_assets/sello_linea_v1_01.png">    </p:cNvPr>
+          <p:cNvPr id="10" name="Image 1" descr="/sessions/sleepy-zen-cray/mnt/outputs/deck_assets/sello_linea_v1_01.png"/>
           <p:cNvPicPr>
             <a:picLocks noChangeAspect="1"/>
           </p:cNvPicPr>
           <p:nvPr/>
         </p:nvPicPr>
         <p:blipFill>
-          <a:blip r:embed="rId2"/>
+          <a:blip r:embed="rId4"/>
           <a:stretch>
             <a:fillRect/>
           </a:stretch>
@@ -6128,7 +5866,7 @@
           <a:bodyPr wrap="square" rtlCol="0" anchor="ctr"/>
           <a:lstStyle/>
           <a:p>
-            <a:pPr indent="0" marL="0">
+            <a:pPr marL="0" indent="0">
               <a:buNone/>
             </a:pPr>
             <a:r>
@@ -6167,7 +5905,7 @@
           <a:bodyPr wrap="square" rtlCol="0" anchor="ctr"/>
           <a:lstStyle/>
           <a:p>
-            <a:pPr algn="r" indent="0" marL="0">
+            <a:pPr marL="0" indent="0" algn="r">
               <a:buNone/>
             </a:pPr>
             <a:r>
@@ -6201,6 +5939,7 @@
         <a:solidFill>
           <a:srgbClr val="FFFFFF"/>
         </a:solidFill>
+        <a:effectLst/>
       </p:bgPr>
     </p:bg>
     <p:spTree>
@@ -6238,11 +5977,11 @@
           <a:bodyPr wrap="square" rtlCol="0" anchor="ctr"/>
           <a:lstStyle/>
           <a:p>
-            <a:pPr indent="0" marL="0">
-              <a:buNone/>
-            </a:pPr>
-            <a:r>
-              <a:rPr lang="en-US" sz="900" b="1" spc="600" kern="0" dirty="0">
+            <a:pPr marL="0" indent="0">
+              <a:buNone/>
+            </a:pPr>
+            <a:r>
+              <a:rPr lang="en-US" sz="900" b="1" kern="0" spc="600" dirty="0">
                 <a:solidFill>
                   <a:srgbClr val="3D2EE8"/>
                 </a:solidFill>
@@ -6277,7 +6016,7 @@
           <a:bodyPr wrap="square" rtlCol="0" anchor="ctr"/>
           <a:lstStyle/>
           <a:p>
-            <a:pPr indent="0" marL="0">
+            <a:pPr marL="0" indent="0">
               <a:buNone/>
             </a:pPr>
             <a:r>
@@ -6343,7 +6082,7 @@
           <a:bodyPr wrap="square" rtlCol="0" anchor="ctr"/>
           <a:lstStyle/>
           <a:p>
-            <a:pPr algn="ctr" indent="0" marL="0">
+            <a:pPr marL="0" indent="0" algn="ctr">
               <a:buNone/>
             </a:pPr>
             <a:r>
@@ -6382,7 +6121,7 @@
           <a:bodyPr wrap="square" rtlCol="0" anchor="ctr"/>
           <a:lstStyle/>
           <a:p>
-            <a:pPr algn="ctr" indent="0" marL="0">
+            <a:pPr marL="0" indent="0" algn="ctr">
               <a:buNone/>
             </a:pPr>
             <a:r>
@@ -6448,7 +6187,7 @@
           <a:bodyPr wrap="square" rtlCol="0" anchor="ctr"/>
           <a:lstStyle/>
           <a:p>
-            <a:pPr algn="ctr" indent="0" marL="0">
+            <a:pPr marL="0" indent="0" algn="ctr">
               <a:buNone/>
             </a:pPr>
             <a:r>
@@ -6487,7 +6226,7 @@
           <a:bodyPr wrap="square" rtlCol="0" anchor="ctr"/>
           <a:lstStyle/>
           <a:p>
-            <a:pPr algn="ctr" indent="0" marL="0">
+            <a:pPr marL="0" indent="0" algn="ctr">
               <a:buNone/>
             </a:pPr>
             <a:r>
@@ -6553,7 +6292,7 @@
           <a:bodyPr wrap="square" rtlCol="0" anchor="ctr"/>
           <a:lstStyle/>
           <a:p>
-            <a:pPr algn="ctr" indent="0" marL="0">
+            <a:pPr marL="0" indent="0" algn="ctr">
               <a:buNone/>
             </a:pPr>
             <a:r>
@@ -6592,7 +6331,7 @@
           <a:bodyPr wrap="square" rtlCol="0" anchor="ctr"/>
           <a:lstStyle/>
           <a:p>
-            <a:pPr algn="ctr" indent="0" marL="0">
+            <a:pPr marL="0" indent="0" algn="ctr">
               <a:buNone/>
             </a:pPr>
             <a:r>
@@ -6658,7 +6397,7 @@
           <a:bodyPr wrap="square" rtlCol="0" anchor="ctr"/>
           <a:lstStyle/>
           <a:p>
-            <a:pPr algn="ctr" indent="0" marL="0">
+            <a:pPr marL="0" indent="0" algn="ctr">
               <a:buNone/>
             </a:pPr>
             <a:r>
@@ -6697,7 +6436,7 @@
           <a:bodyPr wrap="square" rtlCol="0" anchor="ctr"/>
           <a:lstStyle/>
           <a:p>
-            <a:pPr algn="ctr" indent="0" marL="0">
+            <a:pPr marL="0" indent="0" algn="ctr">
               <a:buNone/>
             </a:pPr>
             <a:r>
@@ -6763,7 +6502,7 @@
           <a:bodyPr wrap="square" rtlCol="0" anchor="ctr"/>
           <a:lstStyle/>
           <a:p>
-            <a:pPr algn="ctr" indent="0" marL="0">
+            <a:pPr marL="0" indent="0" algn="ctr">
               <a:buNone/>
             </a:pPr>
             <a:r>
@@ -6802,7 +6541,7 @@
           <a:bodyPr wrap="square" rtlCol="0" anchor="ctr"/>
           <a:lstStyle/>
           <a:p>
-            <a:pPr algn="ctr" indent="0" marL="0">
+            <a:pPr marL="0" indent="0" algn="ctr">
               <a:buNone/>
             </a:pPr>
             <a:r>
@@ -6868,7 +6607,7 @@
           <a:bodyPr wrap="square" rtlCol="0" anchor="ctr"/>
           <a:lstStyle/>
           <a:p>
-            <a:pPr algn="ctr" indent="0" marL="0">
+            <a:pPr marL="0" indent="0" algn="ctr">
               <a:buNone/>
             </a:pPr>
             <a:r>
@@ -6907,7 +6646,7 @@
           <a:bodyPr wrap="square" rtlCol="0" anchor="ctr"/>
           <a:lstStyle/>
           <a:p>
-            <a:pPr algn="ctr" indent="0" marL="0">
+            <a:pPr marL="0" indent="0" algn="ctr">
               <a:buNone/>
             </a:pPr>
             <a:r>
@@ -6973,7 +6712,7 @@
           <a:bodyPr wrap="square" rtlCol="0" anchor="ctr"/>
           <a:lstStyle/>
           <a:p>
-            <a:pPr algn="ctr" indent="0" marL="0">
+            <a:pPr marL="0" indent="0" algn="ctr">
               <a:buNone/>
             </a:pPr>
             <a:r>
@@ -7012,7 +6751,7 @@
           <a:bodyPr wrap="square" rtlCol="0" anchor="ctr"/>
           <a:lstStyle/>
           <a:p>
-            <a:pPr algn="ctr" indent="0" marL="0">
+            <a:pPr marL="0" indent="0" algn="ctr">
               <a:buNone/>
             </a:pPr>
             <a:r>
@@ -7078,7 +6817,7 @@
           <a:bodyPr wrap="square" rtlCol="0" anchor="ctr"/>
           <a:lstStyle/>
           <a:p>
-            <a:pPr algn="ctr" indent="0" marL="0">
+            <a:pPr marL="0" indent="0" algn="ctr">
               <a:buNone/>
             </a:pPr>
             <a:r>
@@ -7117,7 +6856,7 @@
           <a:bodyPr wrap="square" rtlCol="0" anchor="ctr"/>
           <a:lstStyle/>
           <a:p>
-            <a:pPr algn="ctr" indent="0" marL="0">
+            <a:pPr marL="0" indent="0" algn="ctr">
               <a:buNone/>
             </a:pPr>
             <a:r>
@@ -7183,7 +6922,7 @@
           <a:bodyPr wrap="square" rtlCol="0" anchor="ctr"/>
           <a:lstStyle/>
           <a:p>
-            <a:pPr algn="ctr" indent="0" marL="0">
+            <a:pPr marL="0" indent="0" algn="ctr">
               <a:buNone/>
             </a:pPr>
             <a:r>
@@ -7222,7 +6961,7 @@
           <a:bodyPr wrap="square" rtlCol="0" anchor="ctr"/>
           <a:lstStyle/>
           <a:p>
-            <a:pPr algn="ctr" indent="0" marL="0">
+            <a:pPr marL="0" indent="0" algn="ctr">
               <a:buNone/>
             </a:pPr>
             <a:r>
@@ -7288,7 +7027,7 @@
           <a:bodyPr wrap="square" rtlCol="0" anchor="ctr"/>
           <a:lstStyle/>
           <a:p>
-            <a:pPr algn="ctr" indent="0" marL="0">
+            <a:pPr marL="0" indent="0" algn="ctr">
               <a:buNone/>
             </a:pPr>
             <a:r>
@@ -7327,7 +7066,7 @@
           <a:bodyPr wrap="square" rtlCol="0" anchor="ctr"/>
           <a:lstStyle/>
           <a:p>
-            <a:pPr algn="ctr" indent="0" marL="0">
+            <a:pPr marL="0" indent="0" algn="ctr">
               <a:buNone/>
             </a:pPr>
             <a:r>
@@ -7347,14 +7086,14 @@
       </p:sp>
       <p:pic>
         <p:nvPicPr>
-          <p:cNvPr id="34" name="Image 0" descr="/sessions/sleepy-zen-cray/mnt/outputs/deck_assets/logo_var2_azul.png">    </p:cNvPr>
+          <p:cNvPr id="34" name="Image 0" descr="/sessions/sleepy-zen-cray/mnt/outputs/deck_assets/logo_var2_azul.png"/>
           <p:cNvPicPr>
             <a:picLocks noChangeAspect="1"/>
           </p:cNvPicPr>
           <p:nvPr/>
         </p:nvPicPr>
         <p:blipFill>
-          <a:blip r:embed="rId1"/>
+          <a:blip r:embed="rId3"/>
           <a:stretch>
             <a:fillRect/>
           </a:stretch>
@@ -7371,14 +7110,14 @@
       </p:pic>
       <p:pic>
         <p:nvPicPr>
-          <p:cNvPr id="35" name="Image 1" descr="/sessions/sleepy-zen-cray/mnt/outputs/deck_assets/sello_linea_v1_01.png">    </p:cNvPr>
+          <p:cNvPr id="35" name="Image 1" descr="/sessions/sleepy-zen-cray/mnt/outputs/deck_assets/sello_linea_v1_01.png"/>
           <p:cNvPicPr>
             <a:picLocks noChangeAspect="1"/>
           </p:cNvPicPr>
           <p:nvPr/>
         </p:nvPicPr>
         <p:blipFill>
-          <a:blip r:embed="rId2"/>
+          <a:blip r:embed="rId4"/>
           <a:stretch>
             <a:fillRect/>
           </a:stretch>
@@ -7414,7 +7153,7 @@
           <a:bodyPr wrap="square" rtlCol="0" anchor="ctr"/>
           <a:lstStyle/>
           <a:p>
-            <a:pPr indent="0" marL="0">
+            <a:pPr marL="0" indent="0">
               <a:buNone/>
             </a:pPr>
             <a:r>
@@ -7453,7 +7192,7 @@
           <a:bodyPr wrap="square" rtlCol="0" anchor="ctr"/>
           <a:lstStyle/>
           <a:p>
-            <a:pPr algn="r" indent="0" marL="0">
+            <a:pPr marL="0" indent="0" algn="r">
               <a:buNone/>
             </a:pPr>
             <a:r>
@@ -7487,6 +7226,7 @@
         <a:solidFill>
           <a:srgbClr val="FFFFFF"/>
         </a:solidFill>
+        <a:effectLst/>
       </p:bgPr>
     </p:bg>
     <p:spTree>
@@ -7524,11 +7264,11 @@
           <a:bodyPr wrap="square" rtlCol="0" anchor="ctr"/>
           <a:lstStyle/>
           <a:p>
-            <a:pPr indent="0" marL="0">
-              <a:buNone/>
-            </a:pPr>
-            <a:r>
-              <a:rPr lang="en-US" sz="900" b="1" spc="600" kern="0" dirty="0">
+            <a:pPr marL="0" indent="0">
+              <a:buNone/>
+            </a:pPr>
+            <a:r>
+              <a:rPr lang="en-US" sz="900" b="1" kern="0" spc="600" dirty="0">
                 <a:solidFill>
                   <a:srgbClr val="3D2EE8"/>
                 </a:solidFill>
@@ -7563,7 +7303,7 @@
           <a:bodyPr wrap="square" rtlCol="0" anchor="ctr"/>
           <a:lstStyle/>
           <a:p>
-            <a:pPr indent="0" marL="0">
+            <a:pPr marL="0" indent="0">
               <a:buNone/>
             </a:pPr>
             <a:r>
@@ -7602,7 +7342,7 @@
           <a:bodyPr wrap="square" rtlCol="0" anchor="t"/>
           <a:lstStyle/>
           <a:p>
-            <a:pPr indent="0" marL="0">
+            <a:pPr marL="0" indent="0">
               <a:lnSpc>
                 <a:spcPct val="140000"/>
               </a:lnSpc>
@@ -7622,7 +7362,7 @@
             <a:endParaRPr lang="en-US" sz="1400" dirty="0"/>
           </a:p>
           <a:p>
-            <a:pPr indent="0" marL="0">
+            <a:pPr marL="0" indent="0">
               <a:lnSpc>
                 <a:spcPct val="140000"/>
               </a:lnSpc>
@@ -7631,7 +7371,7 @@
             <a:endParaRPr lang="en-US" sz="1400" dirty="0"/>
           </a:p>
           <a:p>
-            <a:pPr indent="0" marL="0">
+            <a:pPr marL="0" indent="0">
               <a:lnSpc>
                 <a:spcPct val="140000"/>
               </a:lnSpc>
@@ -7651,7 +7391,7 @@
             <a:endParaRPr lang="en-US" sz="1400" dirty="0"/>
           </a:p>
           <a:p>
-            <a:pPr indent="0" marL="0">
+            <a:pPr marL="0" indent="0">
               <a:lnSpc>
                 <a:spcPct val="140000"/>
               </a:lnSpc>
@@ -7671,7 +7411,7 @@
             <a:endParaRPr lang="en-US" sz="1400" dirty="0"/>
           </a:p>
           <a:p>
-            <a:pPr indent="0" marL="0">
+            <a:pPr marL="0" indent="0">
               <a:lnSpc>
                 <a:spcPct val="140000"/>
               </a:lnSpc>
@@ -7691,7 +7431,7 @@
             <a:endParaRPr lang="en-US" sz="1400" dirty="0"/>
           </a:p>
           <a:p>
-            <a:pPr indent="0" marL="0">
+            <a:pPr marL="0" indent="0">
               <a:lnSpc>
                 <a:spcPct val="140000"/>
               </a:lnSpc>
@@ -7711,7 +7451,7 @@
             <a:endParaRPr lang="en-US" sz="1400" dirty="0"/>
           </a:p>
           <a:p>
-            <a:pPr indent="0" marL="0">
+            <a:pPr marL="0" indent="0">
               <a:lnSpc>
                 <a:spcPct val="140000"/>
               </a:lnSpc>
@@ -7731,7 +7471,7 @@
             <a:endParaRPr lang="en-US" sz="1400" dirty="0"/>
           </a:p>
           <a:p>
-            <a:pPr indent="0" marL="0">
+            <a:pPr marL="0" indent="0">
               <a:lnSpc>
                 <a:spcPct val="140000"/>
               </a:lnSpc>
@@ -7751,7 +7491,7 @@
             <a:endParaRPr lang="en-US" sz="1400" dirty="0"/>
           </a:p>
           <a:p>
-            <a:pPr indent="0" marL="0">
+            <a:pPr marL="0" indent="0">
               <a:lnSpc>
                 <a:spcPct val="140000"/>
               </a:lnSpc>
@@ -7760,7 +7500,7 @@
             <a:endParaRPr lang="en-US" sz="1400" dirty="0"/>
           </a:p>
           <a:p>
-            <a:pPr indent="0" marL="0">
+            <a:pPr marL="0" indent="0">
               <a:lnSpc>
                 <a:spcPct val="140000"/>
               </a:lnSpc>
@@ -7829,7 +7569,7 @@
           <a:bodyPr wrap="square" rtlCol="0" anchor="ctr"/>
           <a:lstStyle/>
           <a:p>
-            <a:pPr algn="ctr" indent="0" marL="0">
+            <a:pPr marL="0" indent="0" algn="ctr">
               <a:buNone/>
             </a:pPr>
             <a:r>
@@ -7868,7 +7608,7 @@
           <a:bodyPr wrap="square" rtlCol="0" anchor="ctr"/>
           <a:lstStyle/>
           <a:p>
-            <a:pPr algn="ctr" indent="0" marL="0">
+            <a:pPr marL="0" indent="0" algn="ctr">
               <a:buNone/>
             </a:pPr>
             <a:r>
@@ -7907,7 +7647,7 @@
           <a:bodyPr wrap="square" rtlCol="0" anchor="ctr"/>
           <a:lstStyle/>
           <a:p>
-            <a:pPr algn="ctr" indent="0" marL="0">
+            <a:pPr marL="0" indent="0" algn="ctr">
               <a:buNone/>
             </a:pPr>
             <a:r>
@@ -7927,14 +7667,14 @@
       </p:sp>
       <p:pic>
         <p:nvPicPr>
-          <p:cNvPr id="9" name="Image 0" descr="/sessions/sleepy-zen-cray/mnt/outputs/deck_assets/logo_var2_azul.png">    </p:cNvPr>
+          <p:cNvPr id="9" name="Image 0" descr="/sessions/sleepy-zen-cray/mnt/outputs/deck_assets/logo_var2_azul.png"/>
           <p:cNvPicPr>
             <a:picLocks noChangeAspect="1"/>
           </p:cNvPicPr>
           <p:nvPr/>
         </p:nvPicPr>
         <p:blipFill>
-          <a:blip r:embed="rId1"/>
+          <a:blip r:embed="rId3"/>
           <a:stretch>
             <a:fillRect/>
           </a:stretch>
@@ -7951,14 +7691,14 @@
       </p:pic>
       <p:pic>
         <p:nvPicPr>
-          <p:cNvPr id="10" name="Image 1" descr="/sessions/sleepy-zen-cray/mnt/outputs/deck_assets/sello_linea_v1_01.png">    </p:cNvPr>
+          <p:cNvPr id="10" name="Image 1" descr="/sessions/sleepy-zen-cray/mnt/outputs/deck_assets/sello_linea_v1_01.png"/>
           <p:cNvPicPr>
             <a:picLocks noChangeAspect="1"/>
           </p:cNvPicPr>
           <p:nvPr/>
         </p:nvPicPr>
         <p:blipFill>
-          <a:blip r:embed="rId2"/>
+          <a:blip r:embed="rId4"/>
           <a:stretch>
             <a:fillRect/>
           </a:stretch>
@@ -7994,7 +7734,7 @@
           <a:bodyPr wrap="square" rtlCol="0" anchor="ctr"/>
           <a:lstStyle/>
           <a:p>
-            <a:pPr indent="0" marL="0">
+            <a:pPr marL="0" indent="0">
               <a:buNone/>
             </a:pPr>
             <a:r>
@@ -8033,7 +7773,7 @@
           <a:bodyPr wrap="square" rtlCol="0" anchor="ctr"/>
           <a:lstStyle/>
           <a:p>
-            <a:pPr algn="r" indent="0" marL="0">
+            <a:pPr marL="0" indent="0" algn="r">
               <a:buNone/>
             </a:pPr>
             <a:r>
@@ -8067,6 +7807,7 @@
         <a:solidFill>
           <a:srgbClr val="FFFFFF"/>
         </a:solidFill>
+        <a:effectLst/>
       </p:bgPr>
     </p:bg>
     <p:spTree>
@@ -8104,11 +7845,11 @@
           <a:bodyPr wrap="square" rtlCol="0" anchor="ctr"/>
           <a:lstStyle/>
           <a:p>
-            <a:pPr indent="0" marL="0">
-              <a:buNone/>
-            </a:pPr>
-            <a:r>
-              <a:rPr lang="en-US" sz="900" b="1" spc="600" kern="0" dirty="0">
+            <a:pPr marL="0" indent="0">
+              <a:buNone/>
+            </a:pPr>
+            <a:r>
+              <a:rPr lang="en-US" sz="900" b="1" kern="0" spc="600" dirty="0">
                 <a:solidFill>
                   <a:srgbClr val="FF5C5C"/>
                 </a:solidFill>
@@ -8143,7 +7884,7 @@
           <a:bodyPr wrap="square" rtlCol="0" anchor="ctr"/>
           <a:lstStyle/>
           <a:p>
-            <a:pPr indent="0" marL="0">
+            <a:pPr marL="0" indent="0">
               <a:buNone/>
             </a:pPr>
             <a:r>
@@ -8182,7 +7923,7 @@
           <a:bodyPr wrap="square" rtlCol="0" anchor="ctr"/>
           <a:lstStyle/>
           <a:p>
-            <a:pPr indent="0" marL="0">
+            <a:pPr marL="0" indent="0">
               <a:buNone/>
             </a:pPr>
             <a:r>
@@ -8248,7 +7989,7 @@
           <a:bodyPr wrap="square" rtlCol="0" anchor="ctr"/>
           <a:lstStyle/>
           <a:p>
-            <a:pPr algn="ctr" indent="0" marL="0">
+            <a:pPr marL="0" indent="0" algn="ctr">
               <a:buNone/>
             </a:pPr>
             <a:r>
@@ -8287,7 +8028,7 @@
           <a:bodyPr wrap="square" rtlCol="0" anchor="t"/>
           <a:lstStyle/>
           <a:p>
-            <a:pPr algn="ctr" indent="0" marL="0">
+            <a:pPr marL="0" indent="0" algn="ctr">
               <a:buNone/>
             </a:pPr>
             <a:r>
@@ -8353,7 +8094,7 @@
           <a:bodyPr wrap="square" rtlCol="0" anchor="ctr"/>
           <a:lstStyle/>
           <a:p>
-            <a:pPr algn="ctr" indent="0" marL="0">
+            <a:pPr marL="0" indent="0" algn="ctr">
               <a:buNone/>
             </a:pPr>
             <a:r>
@@ -8392,7 +8133,7 @@
           <a:bodyPr wrap="square" rtlCol="0" anchor="t"/>
           <a:lstStyle/>
           <a:p>
-            <a:pPr algn="ctr" indent="0" marL="0">
+            <a:pPr marL="0" indent="0" algn="ctr">
               <a:buNone/>
             </a:pPr>
             <a:r>
@@ -8458,7 +8199,7 @@
           <a:bodyPr wrap="square" rtlCol="0" anchor="ctr"/>
           <a:lstStyle/>
           <a:p>
-            <a:pPr algn="ctr" indent="0" marL="0">
+            <a:pPr marL="0" indent="0" algn="ctr">
               <a:buNone/>
             </a:pPr>
             <a:r>
@@ -8497,7 +8238,7 @@
           <a:bodyPr wrap="square" rtlCol="0" anchor="t"/>
           <a:lstStyle/>
           <a:p>
-            <a:pPr algn="ctr" indent="0" marL="0">
+            <a:pPr marL="0" indent="0" algn="ctr">
               <a:buNone/>
             </a:pPr>
             <a:r>
@@ -8563,7 +8304,7 @@
           <a:bodyPr wrap="square" rtlCol="0" anchor="ctr"/>
           <a:lstStyle/>
           <a:p>
-            <a:pPr algn="ctr" indent="0" marL="0">
+            <a:pPr marL="0" indent="0" algn="ctr">
               <a:buNone/>
             </a:pPr>
             <a:r>
@@ -8602,7 +8343,7 @@
           <a:bodyPr wrap="square" rtlCol="0" anchor="t"/>
           <a:lstStyle/>
           <a:p>
-            <a:pPr algn="ctr" indent="0" marL="0">
+            <a:pPr marL="0" indent="0" algn="ctr">
               <a:buNone/>
             </a:pPr>
             <a:r>
@@ -8668,7 +8409,7 @@
           <a:bodyPr wrap="square" rtlCol="0" anchor="ctr"/>
           <a:lstStyle/>
           <a:p>
-            <a:pPr algn="ctr" indent="0" marL="0">
+            <a:pPr marL="0" indent="0" algn="ctr">
               <a:buNone/>
             </a:pPr>
             <a:r>
@@ -8707,7 +8448,7 @@
           <a:bodyPr wrap="square" rtlCol="0" anchor="t"/>
           <a:lstStyle/>
           <a:p>
-            <a:pPr algn="ctr" indent="0" marL="0">
+            <a:pPr marL="0" indent="0" algn="ctr">
               <a:buNone/>
             </a:pPr>
             <a:r>
@@ -8773,7 +8514,7 @@
           <a:bodyPr wrap="square" rtlCol="0" anchor="ctr"/>
           <a:lstStyle/>
           <a:p>
-            <a:pPr algn="ctr" indent="0" marL="0">
+            <a:pPr marL="0" indent="0" algn="ctr">
               <a:buNone/>
             </a:pPr>
             <a:r>
@@ -8812,7 +8553,7 @@
           <a:bodyPr wrap="square" rtlCol="0" anchor="t"/>
           <a:lstStyle/>
           <a:p>
-            <a:pPr algn="ctr" indent="0" marL="0">
+            <a:pPr marL="0" indent="0" algn="ctr">
               <a:buNone/>
             </a:pPr>
             <a:r>
@@ -8878,7 +8619,7 @@
           <a:bodyPr wrap="square" rtlCol="0" anchor="ctr"/>
           <a:lstStyle/>
           <a:p>
-            <a:pPr algn="ctr" indent="0" marL="0">
+            <a:pPr marL="0" indent="0" algn="ctr">
               <a:buNone/>
             </a:pPr>
             <a:r>
@@ -8917,7 +8658,7 @@
           <a:bodyPr wrap="square" rtlCol="0" anchor="t"/>
           <a:lstStyle/>
           <a:p>
-            <a:pPr algn="ctr" indent="0" marL="0">
+            <a:pPr marL="0" indent="0" algn="ctr">
               <a:buNone/>
             </a:pPr>
             <a:r>
@@ -8983,7 +8724,7 @@
           <a:bodyPr wrap="square" rtlCol="0" anchor="ctr"/>
           <a:lstStyle/>
           <a:p>
-            <a:pPr algn="ctr" indent="0" marL="0">
+            <a:pPr marL="0" indent="0" algn="ctr">
               <a:buNone/>
             </a:pPr>
             <a:r>
@@ -9022,7 +8763,7 @@
           <a:bodyPr wrap="square" rtlCol="0" anchor="t"/>
           <a:lstStyle/>
           <a:p>
-            <a:pPr algn="ctr" indent="0" marL="0">
+            <a:pPr marL="0" indent="0" algn="ctr">
               <a:buNone/>
             </a:pPr>
             <a:r>
@@ -9042,14 +8783,14 @@
       </p:sp>
       <p:pic>
         <p:nvPicPr>
-          <p:cNvPr id="29" name="Image 0" descr="/sessions/sleepy-zen-cray/mnt/outputs/deck_assets/logo_var2_azul.png">    </p:cNvPr>
+          <p:cNvPr id="29" name="Image 0" descr="/sessions/sleepy-zen-cray/mnt/outputs/deck_assets/logo_var2_azul.png"/>
           <p:cNvPicPr>
             <a:picLocks noChangeAspect="1"/>
           </p:cNvPicPr>
           <p:nvPr/>
         </p:nvPicPr>
         <p:blipFill>
-          <a:blip r:embed="rId1"/>
+          <a:blip r:embed="rId3"/>
           <a:stretch>
             <a:fillRect/>
           </a:stretch>
@@ -9066,14 +8807,14 @@
       </p:pic>
       <p:pic>
         <p:nvPicPr>
-          <p:cNvPr id="30" name="Image 1" descr="/sessions/sleepy-zen-cray/mnt/outputs/deck_assets/sello_linea_v1_01.png">    </p:cNvPr>
+          <p:cNvPr id="30" name="Image 1" descr="/sessions/sleepy-zen-cray/mnt/outputs/deck_assets/sello_linea_v1_01.png"/>
           <p:cNvPicPr>
             <a:picLocks noChangeAspect="1"/>
           </p:cNvPicPr>
           <p:nvPr/>
         </p:nvPicPr>
         <p:blipFill>
-          <a:blip r:embed="rId2"/>
+          <a:blip r:embed="rId4"/>
           <a:stretch>
             <a:fillRect/>
           </a:stretch>
@@ -9109,7 +8850,7 @@
           <a:bodyPr wrap="square" rtlCol="0" anchor="ctr"/>
           <a:lstStyle/>
           <a:p>
-            <a:pPr indent="0" marL="0">
+            <a:pPr marL="0" indent="0">
               <a:buNone/>
             </a:pPr>
             <a:r>
@@ -9148,7 +8889,7 @@
           <a:bodyPr wrap="square" rtlCol="0" anchor="ctr"/>
           <a:lstStyle/>
           <a:p>
-            <a:pPr algn="r" indent="0" marL="0">
+            <a:pPr marL="0" indent="0" algn="r">
               <a:buNone/>
             </a:pPr>
             <a:r>
@@ -9182,6 +8923,7 @@
         <a:solidFill>
           <a:srgbClr val="FFFFFF"/>
         </a:solidFill>
+        <a:effectLst/>
       </p:bgPr>
     </p:bg>
     <p:spTree>
@@ -9219,11 +8961,11 @@
           <a:bodyPr wrap="square" rtlCol="0" anchor="ctr"/>
           <a:lstStyle/>
           <a:p>
-            <a:pPr indent="0" marL="0">
-              <a:buNone/>
-            </a:pPr>
-            <a:r>
-              <a:rPr lang="en-US" sz="900" b="1" spc="600" kern="0" dirty="0">
+            <a:pPr marL="0" indent="0">
+              <a:buNone/>
+            </a:pPr>
+            <a:r>
+              <a:rPr lang="en-US" sz="900" b="1" kern="0" spc="600" dirty="0">
                 <a:solidFill>
                   <a:srgbClr val="3D2EE8"/>
                 </a:solidFill>
@@ -9258,7 +9000,7 @@
           <a:bodyPr wrap="square" rtlCol="0" anchor="ctr"/>
           <a:lstStyle/>
           <a:p>
-            <a:pPr indent="0" marL="0">
+            <a:pPr marL="0" indent="0">
               <a:buNone/>
             </a:pPr>
             <a:r>
@@ -9324,7 +9066,7 @@
           <a:bodyPr wrap="square" rtlCol="0" anchor="ctr"/>
           <a:lstStyle/>
           <a:p>
-            <a:pPr algn="ctr" indent="0" marL="0">
+            <a:pPr marL="0" indent="0" algn="ctr">
               <a:buNone/>
             </a:pPr>
             <a:r>
@@ -9363,7 +9105,7 @@
           <a:bodyPr wrap="square" rtlCol="0" anchor="ctr"/>
           <a:lstStyle/>
           <a:p>
-            <a:pPr algn="ctr" indent="0" marL="0">
+            <a:pPr marL="0" indent="0" algn="ctr">
               <a:buNone/>
             </a:pPr>
             <a:r>
@@ -9429,7 +9171,7 @@
           <a:bodyPr wrap="square" rtlCol="0" anchor="ctr"/>
           <a:lstStyle/>
           <a:p>
-            <a:pPr algn="ctr" indent="0" marL="0">
+            <a:pPr marL="0" indent="0" algn="ctr">
               <a:buNone/>
             </a:pPr>
             <a:r>
@@ -9468,7 +9210,7 @@
           <a:bodyPr wrap="square" rtlCol="0" anchor="ctr"/>
           <a:lstStyle/>
           <a:p>
-            <a:pPr algn="ctr" indent="0" marL="0">
+            <a:pPr marL="0" indent="0" algn="ctr">
               <a:buNone/>
             </a:pPr>
             <a:r>
@@ -9534,7 +9276,7 @@
           <a:bodyPr wrap="square" rtlCol="0" anchor="ctr"/>
           <a:lstStyle/>
           <a:p>
-            <a:pPr algn="ctr" indent="0" marL="0">
+            <a:pPr marL="0" indent="0" algn="ctr">
               <a:buNone/>
             </a:pPr>
             <a:r>
@@ -9573,7 +9315,7 @@
           <a:bodyPr wrap="square" rtlCol="0" anchor="ctr"/>
           <a:lstStyle/>
           <a:p>
-            <a:pPr algn="ctr" indent="0" marL="0">
+            <a:pPr marL="0" indent="0" algn="ctr">
               <a:buNone/>
             </a:pPr>
             <a:r>
@@ -9639,7 +9381,7 @@
           <a:bodyPr wrap="square" rtlCol="0" anchor="ctr"/>
           <a:lstStyle/>
           <a:p>
-            <a:pPr algn="ctr" indent="0" marL="0">
+            <a:pPr marL="0" indent="0" algn="ctr">
               <a:buNone/>
             </a:pPr>
             <a:r>
@@ -9678,7 +9420,7 @@
           <a:bodyPr wrap="square" rtlCol="0" anchor="ctr"/>
           <a:lstStyle/>
           <a:p>
-            <a:pPr algn="ctr" indent="0" marL="0">
+            <a:pPr marL="0" indent="0" algn="ctr">
               <a:buNone/>
             </a:pPr>
             <a:r>
@@ -9744,7 +9486,7 @@
           <a:bodyPr wrap="square" rtlCol="0" anchor="ctr"/>
           <a:lstStyle/>
           <a:p>
-            <a:pPr algn="ctr" indent="0" marL="0">
+            <a:pPr marL="0" indent="0" algn="ctr">
               <a:buNone/>
             </a:pPr>
             <a:r>
@@ -9783,7 +9525,7 @@
           <a:bodyPr wrap="square" rtlCol="0" anchor="ctr"/>
           <a:lstStyle/>
           <a:p>
-            <a:pPr algn="ctr" indent="0" marL="0">
+            <a:pPr marL="0" indent="0" algn="ctr">
               <a:buNone/>
             </a:pPr>
             <a:r>
@@ -9849,7 +9591,7 @@
           <a:bodyPr wrap="square" rtlCol="0" anchor="ctr"/>
           <a:lstStyle/>
           <a:p>
-            <a:pPr algn="ctr" indent="0" marL="0">
+            <a:pPr marL="0" indent="0" algn="ctr">
               <a:buNone/>
             </a:pPr>
             <a:r>
@@ -9888,7 +9630,7 @@
           <a:bodyPr wrap="square" rtlCol="0" anchor="ctr"/>
           <a:lstStyle/>
           <a:p>
-            <a:pPr algn="ctr" indent="0" marL="0">
+            <a:pPr marL="0" indent="0" algn="ctr">
               <a:buNone/>
             </a:pPr>
             <a:r>
@@ -9954,7 +9696,7 @@
           <a:bodyPr wrap="square" rtlCol="0" anchor="ctr"/>
           <a:lstStyle/>
           <a:p>
-            <a:pPr algn="ctr" indent="0" marL="0">
+            <a:pPr marL="0" indent="0" algn="ctr">
               <a:buNone/>
             </a:pPr>
             <a:r>
@@ -9993,7 +9735,7 @@
           <a:bodyPr wrap="square" rtlCol="0" anchor="ctr"/>
           <a:lstStyle/>
           <a:p>
-            <a:pPr algn="ctr" indent="0" marL="0">
+            <a:pPr marL="0" indent="0" algn="ctr">
               <a:buNone/>
             </a:pPr>
             <a:r>
@@ -10059,7 +9801,7 @@
           <a:bodyPr wrap="square" rtlCol="0" anchor="ctr"/>
           <a:lstStyle/>
           <a:p>
-            <a:pPr algn="ctr" indent="0" marL="0">
+            <a:pPr marL="0" indent="0" algn="ctr">
               <a:buNone/>
             </a:pPr>
             <a:r>
@@ -10098,7 +9840,7 @@
           <a:bodyPr wrap="square" rtlCol="0" anchor="ctr"/>
           <a:lstStyle/>
           <a:p>
-            <a:pPr algn="ctr" indent="0" marL="0">
+            <a:pPr marL="0" indent="0" algn="ctr">
               <a:buNone/>
             </a:pPr>
             <a:r>
@@ -10164,7 +9906,7 @@
           <a:bodyPr wrap="square" rtlCol="0" anchor="ctr"/>
           <a:lstStyle/>
           <a:p>
-            <a:pPr algn="ctr" indent="0" marL="0">
+            <a:pPr marL="0" indent="0" algn="ctr">
               <a:buNone/>
             </a:pPr>
             <a:r>
@@ -10203,7 +9945,7 @@
           <a:bodyPr wrap="square" rtlCol="0" anchor="ctr"/>
           <a:lstStyle/>
           <a:p>
-            <a:pPr algn="ctr" indent="0" marL="0">
+            <a:pPr marL="0" indent="0" algn="ctr">
               <a:buNone/>
             </a:pPr>
             <a:r>
@@ -10269,7 +10011,7 @@
           <a:bodyPr wrap="square" rtlCol="0" anchor="ctr"/>
           <a:lstStyle/>
           <a:p>
-            <a:pPr algn="ctr" indent="0" marL="0">
+            <a:pPr marL="0" indent="0" algn="ctr">
               <a:buNone/>
             </a:pPr>
             <a:r>
@@ -10308,7 +10050,7 @@
           <a:bodyPr wrap="square" rtlCol="0" anchor="ctr"/>
           <a:lstStyle/>
           <a:p>
-            <a:pPr algn="ctr" indent="0" marL="0">
+            <a:pPr marL="0" indent="0" algn="ctr">
               <a:buNone/>
             </a:pPr>
             <a:r>
@@ -10374,7 +10116,7 @@
           <a:bodyPr wrap="square" rtlCol="0" anchor="ctr"/>
           <a:lstStyle/>
           <a:p>
-            <a:pPr algn="ctr" indent="0" marL="0">
+            <a:pPr marL="0" indent="0" algn="ctr">
               <a:buNone/>
             </a:pPr>
             <a:r>
@@ -10413,7 +10155,7 @@
           <a:bodyPr wrap="square" rtlCol="0" anchor="ctr"/>
           <a:lstStyle/>
           <a:p>
-            <a:pPr algn="ctr" indent="0" marL="0">
+            <a:pPr marL="0" indent="0" algn="ctr">
               <a:buNone/>
             </a:pPr>
             <a:r>
@@ -10479,7 +10221,7 @@
           <a:bodyPr wrap="square" rtlCol="0" anchor="ctr"/>
           <a:lstStyle/>
           <a:p>
-            <a:pPr algn="ctr" indent="0" marL="0">
+            <a:pPr marL="0" indent="0" algn="ctr">
               <a:buNone/>
             </a:pPr>
             <a:r>
@@ -10518,7 +10260,7 @@
           <a:bodyPr wrap="square" rtlCol="0" anchor="ctr"/>
           <a:lstStyle/>
           <a:p>
-            <a:pPr algn="ctr" indent="0" marL="0">
+            <a:pPr marL="0" indent="0" algn="ctr">
               <a:buNone/>
             </a:pPr>
             <a:r>
@@ -10538,14 +10280,14 @@
       </p:sp>
       <p:pic>
         <p:nvPicPr>
-          <p:cNvPr id="40" name="Image 0" descr="/sessions/sleepy-zen-cray/mnt/outputs/deck_assets/logo_var2_azul.png">    </p:cNvPr>
+          <p:cNvPr id="40" name="Image 0" descr="/sessions/sleepy-zen-cray/mnt/outputs/deck_assets/logo_var2_azul.png"/>
           <p:cNvPicPr>
             <a:picLocks noChangeAspect="1"/>
           </p:cNvPicPr>
           <p:nvPr/>
         </p:nvPicPr>
         <p:blipFill>
-          <a:blip r:embed="rId1"/>
+          <a:blip r:embed="rId3"/>
           <a:stretch>
             <a:fillRect/>
           </a:stretch>
@@ -10562,14 +10304,14 @@
       </p:pic>
       <p:pic>
         <p:nvPicPr>
-          <p:cNvPr id="41" name="Image 1" descr="/sessions/sleepy-zen-cray/mnt/outputs/deck_assets/sello_linea_v1_01.png">    </p:cNvPr>
+          <p:cNvPr id="41" name="Image 1" descr="/sessions/sleepy-zen-cray/mnt/outputs/deck_assets/sello_linea_v1_01.png"/>
           <p:cNvPicPr>
             <a:picLocks noChangeAspect="1"/>
           </p:cNvPicPr>
           <p:nvPr/>
         </p:nvPicPr>
         <p:blipFill>
-          <a:blip r:embed="rId2"/>
+          <a:blip r:embed="rId4"/>
           <a:stretch>
             <a:fillRect/>
           </a:stretch>
@@ -10605,7 +10347,7 @@
           <a:bodyPr wrap="square" rtlCol="0" anchor="ctr"/>
           <a:lstStyle/>
           <a:p>
-            <a:pPr indent="0" marL="0">
+            <a:pPr marL="0" indent="0">
               <a:buNone/>
             </a:pPr>
             <a:r>
@@ -10644,7 +10386,7 @@
           <a:bodyPr wrap="square" rtlCol="0" anchor="ctr"/>
           <a:lstStyle/>
           <a:p>
-            <a:pPr algn="r" indent="0" marL="0">
+            <a:pPr marL="0" indent="0" algn="r">
               <a:buNone/>
             </a:pPr>
             <a:r>
@@ -10678,6 +10420,7 @@
         <a:solidFill>
           <a:srgbClr val="FFFFFF"/>
         </a:solidFill>
+        <a:effectLst/>
       </p:bgPr>
     </p:bg>
     <p:spTree>
@@ -10715,11 +10458,11 @@
           <a:bodyPr wrap="square" rtlCol="0" anchor="ctr"/>
           <a:lstStyle/>
           <a:p>
-            <a:pPr indent="0" marL="0">
-              <a:buNone/>
-            </a:pPr>
-            <a:r>
-              <a:rPr lang="en-US" sz="900" b="1" spc="600" kern="0" dirty="0">
+            <a:pPr marL="0" indent="0">
+              <a:buNone/>
+            </a:pPr>
+            <a:r>
+              <a:rPr lang="en-US" sz="900" b="1" kern="0" spc="600" dirty="0">
                 <a:solidFill>
                   <a:srgbClr val="3D2EE8"/>
                 </a:solidFill>
@@ -10754,7 +10497,7 @@
           <a:bodyPr wrap="square" rtlCol="0" anchor="ctr"/>
           <a:lstStyle/>
           <a:p>
-            <a:pPr indent="0" marL="0">
+            <a:pPr marL="0" indent="0">
               <a:buNone/>
             </a:pPr>
             <a:r>
@@ -10793,7 +10536,7 @@
           <a:bodyPr wrap="square" rtlCol="0" anchor="t"/>
           <a:lstStyle/>
           <a:p>
-            <a:pPr indent="0" marL="0">
+            <a:pPr marL="0" indent="0">
               <a:lnSpc>
                 <a:spcPct val="140000"/>
               </a:lnSpc>
@@ -10813,7 +10556,7 @@
             <a:endParaRPr lang="en-US" sz="1400" dirty="0"/>
           </a:p>
           <a:p>
-            <a:pPr indent="0" marL="0">
+            <a:pPr marL="0" indent="0">
               <a:lnSpc>
                 <a:spcPct val="140000"/>
               </a:lnSpc>
@@ -10822,7 +10565,7 @@
             <a:endParaRPr lang="en-US" sz="1400" dirty="0"/>
           </a:p>
           <a:p>
-            <a:pPr indent="0" marL="0">
+            <a:pPr marL="0" indent="0">
               <a:lnSpc>
                 <a:spcPct val="140000"/>
               </a:lnSpc>
@@ -10842,7 +10585,7 @@
             <a:endParaRPr lang="en-US" sz="1400" dirty="0"/>
           </a:p>
           <a:p>
-            <a:pPr indent="0" marL="0">
+            <a:pPr marL="0" indent="0">
               <a:lnSpc>
                 <a:spcPct val="140000"/>
               </a:lnSpc>
@@ -10862,7 +10605,7 @@
             <a:endParaRPr lang="en-US" sz="1400" dirty="0"/>
           </a:p>
           <a:p>
-            <a:pPr indent="0" marL="0">
+            <a:pPr marL="0" indent="0">
               <a:lnSpc>
                 <a:spcPct val="140000"/>
               </a:lnSpc>
@@ -10882,7 +10625,7 @@
             <a:endParaRPr lang="en-US" sz="1400" dirty="0"/>
           </a:p>
           <a:p>
-            <a:pPr indent="0" marL="0">
+            <a:pPr marL="0" indent="0">
               <a:lnSpc>
                 <a:spcPct val="140000"/>
               </a:lnSpc>
@@ -10891,7 +10634,7 @@
             <a:endParaRPr lang="en-US" sz="1400" dirty="0"/>
           </a:p>
           <a:p>
-            <a:pPr indent="0" marL="0">
+            <a:pPr marL="0" indent="0">
               <a:lnSpc>
                 <a:spcPct val="140000"/>
               </a:lnSpc>
@@ -10911,7 +10654,7 @@
             <a:endParaRPr lang="en-US" sz="1400" dirty="0"/>
           </a:p>
           <a:p>
-            <a:pPr indent="0" marL="0">
+            <a:pPr marL="0" indent="0">
               <a:lnSpc>
                 <a:spcPct val="140000"/>
               </a:lnSpc>
@@ -10920,7 +10663,7 @@
             <a:endParaRPr lang="en-US" sz="1400" dirty="0"/>
           </a:p>
           <a:p>
-            <a:pPr indent="0" marL="0">
+            <a:pPr marL="0" indent="0">
               <a:lnSpc>
                 <a:spcPct val="140000"/>
               </a:lnSpc>
@@ -10989,7 +10732,7 @@
           <a:bodyPr wrap="square" rtlCol="0" anchor="ctr"/>
           <a:lstStyle/>
           <a:p>
-            <a:pPr algn="ctr" indent="0" marL="0">
+            <a:pPr marL="0" indent="0" algn="ctr">
               <a:buNone/>
             </a:pPr>
             <a:r>
@@ -11028,7 +10771,7 @@
           <a:bodyPr wrap="square" rtlCol="0" anchor="ctr"/>
           <a:lstStyle/>
           <a:p>
-            <a:pPr algn="ctr" indent="0" marL="0">
+            <a:pPr marL="0" indent="0" algn="ctr">
               <a:buNone/>
             </a:pPr>
             <a:r>
@@ -11067,7 +10810,7 @@
           <a:bodyPr wrap="square" rtlCol="0" anchor="ctr"/>
           <a:lstStyle/>
           <a:p>
-            <a:pPr algn="ctr" indent="0" marL="0">
+            <a:pPr marL="0" indent="0" algn="ctr">
               <a:buNone/>
             </a:pPr>
             <a:r>
@@ -11087,14 +10830,14 @@
       </p:sp>
       <p:pic>
         <p:nvPicPr>
-          <p:cNvPr id="9" name="Image 0" descr="/sessions/sleepy-zen-cray/mnt/outputs/deck_assets/logo_var2_azul.png">    </p:cNvPr>
+          <p:cNvPr id="9" name="Image 0" descr="/sessions/sleepy-zen-cray/mnt/outputs/deck_assets/logo_var2_azul.png"/>
           <p:cNvPicPr>
             <a:picLocks noChangeAspect="1"/>
           </p:cNvPicPr>
           <p:nvPr/>
         </p:nvPicPr>
         <p:blipFill>
-          <a:blip r:embed="rId1"/>
+          <a:blip r:embed="rId3"/>
           <a:stretch>
             <a:fillRect/>
           </a:stretch>
@@ -11111,14 +10854,14 @@
       </p:pic>
       <p:pic>
         <p:nvPicPr>
-          <p:cNvPr id="10" name="Image 1" descr="/sessions/sleepy-zen-cray/mnt/outputs/deck_assets/sello_linea_v1_01.png">    </p:cNvPr>
+          <p:cNvPr id="10" name="Image 1" descr="/sessions/sleepy-zen-cray/mnt/outputs/deck_assets/sello_linea_v1_01.png"/>
           <p:cNvPicPr>
             <a:picLocks noChangeAspect="1"/>
           </p:cNvPicPr>
           <p:nvPr/>
         </p:nvPicPr>
         <p:blipFill>
-          <a:blip r:embed="rId2"/>
+          <a:blip r:embed="rId4"/>
           <a:stretch>
             <a:fillRect/>
           </a:stretch>
@@ -11154,7 +10897,7 @@
           <a:bodyPr wrap="square" rtlCol="0" anchor="ctr"/>
           <a:lstStyle/>
           <a:p>
-            <a:pPr indent="0" marL="0">
+            <a:pPr marL="0" indent="0">
               <a:buNone/>
             </a:pPr>
             <a:r>
@@ -11193,7 +10936,7 @@
           <a:bodyPr wrap="square" rtlCol="0" anchor="ctr"/>
           <a:lstStyle/>
           <a:p>
-            <a:pPr algn="r" indent="0" marL="0">
+            <a:pPr marL="0" indent="0" algn="r">
               <a:buNone/>
             </a:pPr>
             <a:r>
@@ -11227,6 +10970,7 @@
         <a:solidFill>
           <a:srgbClr val="FFFFFF"/>
         </a:solidFill>
+        <a:effectLst/>
       </p:bgPr>
     </p:bg>
     <p:spTree>
@@ -11264,11 +11008,11 @@
           <a:bodyPr wrap="square" rtlCol="0" anchor="ctr"/>
           <a:lstStyle/>
           <a:p>
-            <a:pPr indent="0" marL="0">
-              <a:buNone/>
-            </a:pPr>
-            <a:r>
-              <a:rPr lang="en-US" sz="900" b="1" spc="600" kern="0" dirty="0">
+            <a:pPr marL="0" indent="0">
+              <a:buNone/>
+            </a:pPr>
+            <a:r>
+              <a:rPr lang="en-US" sz="900" b="1" kern="0" spc="600" dirty="0">
                 <a:solidFill>
                   <a:srgbClr val="3D2EE8"/>
                 </a:solidFill>
@@ -11303,7 +11047,7 @@
           <a:bodyPr wrap="square" rtlCol="0" anchor="ctr"/>
           <a:lstStyle/>
           <a:p>
-            <a:pPr indent="0" marL="0">
+            <a:pPr marL="0" indent="0">
               <a:buNone/>
             </a:pPr>
             <a:r>
@@ -11369,7 +11113,7 @@
           <a:bodyPr wrap="square" rtlCol="0" anchor="ctr"/>
           <a:lstStyle/>
           <a:p>
-            <a:pPr algn="ctr" indent="0" marL="0">
+            <a:pPr marL="0" indent="0" algn="ctr">
               <a:buNone/>
             </a:pPr>
             <a:r>
@@ -11408,7 +11152,7 @@
           <a:bodyPr wrap="square" rtlCol="0" anchor="ctr"/>
           <a:lstStyle/>
           <a:p>
-            <a:pPr algn="ctr" indent="0" marL="0">
+            <a:pPr marL="0" indent="0" algn="ctr">
               <a:buNone/>
             </a:pPr>
             <a:r>
@@ -11474,7 +11218,7 @@
           <a:bodyPr wrap="square" rtlCol="0" anchor="ctr"/>
           <a:lstStyle/>
           <a:p>
-            <a:pPr algn="ctr" indent="0" marL="0">
+            <a:pPr marL="0" indent="0" algn="ctr">
               <a:buNone/>
             </a:pPr>
             <a:r>
@@ -11513,7 +11257,7 @@
           <a:bodyPr wrap="square" rtlCol="0" anchor="ctr"/>
           <a:lstStyle/>
           <a:p>
-            <a:pPr algn="ctr" indent="0" marL="0">
+            <a:pPr marL="0" indent="0" algn="ctr">
               <a:buNone/>
             </a:pPr>
             <a:r>
@@ -11579,7 +11323,7 @@
           <a:bodyPr wrap="square" rtlCol="0" anchor="ctr"/>
           <a:lstStyle/>
           <a:p>
-            <a:pPr algn="ctr" indent="0" marL="0">
+            <a:pPr marL="0" indent="0" algn="ctr">
               <a:buNone/>
             </a:pPr>
             <a:r>
@@ -11618,7 +11362,7 @@
           <a:bodyPr wrap="square" rtlCol="0" anchor="ctr"/>
           <a:lstStyle/>
           <a:p>
-            <a:pPr algn="ctr" indent="0" marL="0">
+            <a:pPr marL="0" indent="0" algn="ctr">
               <a:buNone/>
             </a:pPr>
             <a:r>
@@ -11684,7 +11428,7 @@
           <a:bodyPr wrap="square" rtlCol="0" anchor="ctr"/>
           <a:lstStyle/>
           <a:p>
-            <a:pPr algn="ctr" indent="0" marL="0">
+            <a:pPr marL="0" indent="0" algn="ctr">
               <a:buNone/>
             </a:pPr>
             <a:r>
@@ -11723,7 +11467,7 @@
           <a:bodyPr wrap="square" rtlCol="0" anchor="ctr"/>
           <a:lstStyle/>
           <a:p>
-            <a:pPr algn="ctr" indent="0" marL="0">
+            <a:pPr marL="0" indent="0" algn="ctr">
               <a:buNone/>
             </a:pPr>
             <a:r>
@@ -11789,7 +11533,7 @@
           <a:bodyPr wrap="square" rtlCol="0" anchor="ctr"/>
           <a:lstStyle/>
           <a:p>
-            <a:pPr algn="ctr" indent="0" marL="0">
+            <a:pPr marL="0" indent="0" algn="ctr">
               <a:buNone/>
             </a:pPr>
             <a:r>
@@ -11828,7 +11572,7 @@
           <a:bodyPr wrap="square" rtlCol="0" anchor="ctr"/>
           <a:lstStyle/>
           <a:p>
-            <a:pPr algn="ctr" indent="0" marL="0">
+            <a:pPr marL="0" indent="0" algn="ctr">
               <a:buNone/>
             </a:pPr>
             <a:r>
@@ -11894,7 +11638,7 @@
           <a:bodyPr wrap="square" rtlCol="0" anchor="ctr"/>
           <a:lstStyle/>
           <a:p>
-            <a:pPr algn="ctr" indent="0" marL="0">
+            <a:pPr marL="0" indent="0" algn="ctr">
               <a:buNone/>
             </a:pPr>
             <a:r>
@@ -11933,7 +11677,7 @@
           <a:bodyPr wrap="square" rtlCol="0" anchor="ctr"/>
           <a:lstStyle/>
           <a:p>
-            <a:pPr algn="ctr" indent="0" marL="0">
+            <a:pPr marL="0" indent="0" algn="ctr">
               <a:buNone/>
             </a:pPr>
             <a:r>
@@ -11999,7 +11743,7 @@
           <a:bodyPr wrap="square" rtlCol="0" anchor="ctr"/>
           <a:lstStyle/>
           <a:p>
-            <a:pPr algn="ctr" indent="0" marL="0">
+            <a:pPr marL="0" indent="0" algn="ctr">
               <a:buNone/>
             </a:pPr>
             <a:r>
@@ -12038,7 +11782,7 @@
           <a:bodyPr wrap="square" rtlCol="0" anchor="ctr"/>
           <a:lstStyle/>
           <a:p>
-            <a:pPr algn="ctr" indent="0" marL="0">
+            <a:pPr marL="0" indent="0" algn="ctr">
               <a:buNone/>
             </a:pPr>
             <a:r>
@@ -12058,14 +11802,14 @@
       </p:sp>
       <p:pic>
         <p:nvPicPr>
-          <p:cNvPr id="25" name="Image 0" descr="/sessions/sleepy-zen-cray/mnt/outputs/deck_assets/logo_var2_azul.png">    </p:cNvPr>
+          <p:cNvPr id="25" name="Image 0" descr="/sessions/sleepy-zen-cray/mnt/outputs/deck_assets/logo_var2_azul.png"/>
           <p:cNvPicPr>
             <a:picLocks noChangeAspect="1"/>
           </p:cNvPicPr>
           <p:nvPr/>
         </p:nvPicPr>
         <p:blipFill>
-          <a:blip r:embed="rId1"/>
+          <a:blip r:embed="rId3"/>
           <a:stretch>
             <a:fillRect/>
           </a:stretch>
@@ -12082,14 +11826,14 @@
       </p:pic>
       <p:pic>
         <p:nvPicPr>
-          <p:cNvPr id="26" name="Image 1" descr="/sessions/sleepy-zen-cray/mnt/outputs/deck_assets/sello_linea_v1_01.png">    </p:cNvPr>
+          <p:cNvPr id="26" name="Image 1" descr="/sessions/sleepy-zen-cray/mnt/outputs/deck_assets/sello_linea_v1_01.png"/>
           <p:cNvPicPr>
             <a:picLocks noChangeAspect="1"/>
           </p:cNvPicPr>
           <p:nvPr/>
         </p:nvPicPr>
         <p:blipFill>
-          <a:blip r:embed="rId2"/>
+          <a:blip r:embed="rId4"/>
           <a:stretch>
             <a:fillRect/>
           </a:stretch>
@@ -12125,7 +11869,7 @@
           <a:bodyPr wrap="square" rtlCol="0" anchor="ctr"/>
           <a:lstStyle/>
           <a:p>
-            <a:pPr indent="0" marL="0">
+            <a:pPr marL="0" indent="0">
               <a:buNone/>
             </a:pPr>
             <a:r>
@@ -12164,7 +11908,7 @@
           <a:bodyPr wrap="square" rtlCol="0" anchor="ctr"/>
           <a:lstStyle/>
           <a:p>
-            <a:pPr algn="r" indent="0" marL="0">
+            <a:pPr marL="0" indent="0" algn="r">
               <a:buNone/>
             </a:pPr>
             <a:r>
@@ -12483,4 +12227,299 @@
     </a:ext>
   </a:extLst>
 </a:theme>
+</file>
+
+<file path=ppt/theme/theme2.xml><?xml version="1.0" encoding="utf-8"?>
+<a:theme xmlns:a="http://schemas.openxmlformats.org/drawingml/2006/main" name="Office Theme">
+  <a:themeElements>
+    <a:clrScheme name="Office">
+      <a:dk1>
+        <a:sysClr val="windowText" lastClr="000000"/>
+      </a:dk1>
+      <a:lt1>
+        <a:sysClr val="window" lastClr="FFFFFF"/>
+      </a:lt1>
+      <a:dk2>
+        <a:srgbClr val="44546A"/>
+      </a:dk2>
+      <a:lt2>
+        <a:srgbClr val="E7E6E6"/>
+      </a:lt2>
+      <a:accent1>
+        <a:srgbClr val="4472C4"/>
+      </a:accent1>
+      <a:accent2>
+        <a:srgbClr val="ED7D31"/>
+      </a:accent2>
+      <a:accent3>
+        <a:srgbClr val="A5A5A5"/>
+      </a:accent3>
+      <a:accent4>
+        <a:srgbClr val="FFC000"/>
+      </a:accent4>
+      <a:accent5>
+        <a:srgbClr val="5B9BD5"/>
+      </a:accent5>
+      <a:accent6>
+        <a:srgbClr val="70AD47"/>
+      </a:accent6>
+      <a:hlink>
+        <a:srgbClr val="0563C1"/>
+      </a:hlink>
+      <a:folHlink>
+        <a:srgbClr val="954F72"/>
+      </a:folHlink>
+    </a:clrScheme>
+    <a:fontScheme name="Office">
+      <a:majorFont>
+        <a:latin typeface="Calibri Light" panose="020F0302020204030204"/>
+        <a:ea typeface=""/>
+        <a:cs typeface=""/>
+        <a:font script="Jpan" typeface="游ゴシック Light"/>
+        <a:font script="Hang" typeface="맑은 고딕"/>
+        <a:font script="Hans" typeface="等线 Light"/>
+        <a:font script="Hant" typeface="新細明體"/>
+        <a:font script="Arab" typeface="Times New Roman"/>
+        <a:font script="Hebr" typeface="Times New Roman"/>
+        <a:font script="Thai" typeface="Angsana New"/>
+        <a:font script="Ethi" typeface="Nyala"/>
+        <a:font script="Beng" typeface="Vrinda"/>
+        <a:font script="Gujr" typeface="Shruti"/>
+        <a:font script="Khmr" typeface="MoolBoran"/>
+        <a:font script="Knda" typeface="Tunga"/>
+        <a:font script="Guru" typeface="Raavi"/>
+        <a:font script="Cans" typeface="Euphemia"/>
+        <a:font script="Cher" typeface="Plantagenet Cherokee"/>
+        <a:font script="Yiii" typeface="Microsoft Yi Baiti"/>
+        <a:font script="Tibt" typeface="Microsoft Himalaya"/>
+        <a:font script="Thaa" typeface="MV Boli"/>
+        <a:font script="Deva" typeface="Mangal"/>
+        <a:font script="Telu" typeface="Gautami"/>
+        <a:font script="Taml" typeface="Latha"/>
+        <a:font script="Syrc" typeface="Estrangelo Edessa"/>
+        <a:font script="Orya" typeface="Kalinga"/>
+        <a:font script="Mlym" typeface="Kartika"/>
+        <a:font script="Laoo" typeface="DokChampa"/>
+        <a:font script="Sinh" typeface="Iskoola Pota"/>
+        <a:font script="Mong" typeface="Mongolian Baiti"/>
+        <a:font script="Viet" typeface="Times New Roman"/>
+        <a:font script="Uigh" typeface="Microsoft Uighur"/>
+        <a:font script="Geor" typeface="Sylfaen"/>
+        <a:font script="Armn" typeface="Arial"/>
+        <a:font script="Bugi" typeface="Leelawadee UI"/>
+        <a:font script="Bopo" typeface="Microsoft JhengHei"/>
+        <a:font script="Java" typeface="Javanese Text"/>
+        <a:font script="Lisu" typeface="Segoe UI"/>
+        <a:font script="Mymr" typeface="Myanmar Text"/>
+        <a:font script="Nkoo" typeface="Ebrima"/>
+        <a:font script="Olck" typeface="Nirmala UI"/>
+        <a:font script="Osma" typeface="Ebrima"/>
+        <a:font script="Phag" typeface="Phagspa"/>
+        <a:font script="Syrn" typeface="Estrangelo Edessa"/>
+        <a:font script="Syrj" typeface="Estrangelo Edessa"/>
+        <a:font script="Syre" typeface="Estrangelo Edessa"/>
+        <a:font script="Sora" typeface="Nirmala UI"/>
+        <a:font script="Tale" typeface="Microsoft Tai Le"/>
+        <a:font script="Talu" typeface="Microsoft New Tai Lue"/>
+        <a:font script="Tfng" typeface="Ebrima"/>
+      </a:majorFont>
+      <a:minorFont>
+        <a:latin typeface="Calibri" panose="020F0502020204030204"/>
+        <a:ea typeface=""/>
+        <a:cs typeface=""/>
+        <a:font script="Jpan" typeface="游ゴシック"/>
+        <a:font script="Hang" typeface="맑은 고딕"/>
+        <a:font script="Hans" typeface="等线"/>
+        <a:font script="Hant" typeface="新細明體"/>
+        <a:font script="Arab" typeface="Arial"/>
+        <a:font script="Hebr" typeface="Arial"/>
+        <a:font script="Thai" typeface="Cordia New"/>
+        <a:font script="Ethi" typeface="Nyala"/>
+        <a:font script="Beng" typeface="Vrinda"/>
+        <a:font script="Gujr" typeface="Shruti"/>
+        <a:font script="Khmr" typeface="DaunPenh"/>
+        <a:font script="Knda" typeface="Tunga"/>
+        <a:font script="Guru" typeface="Raavi"/>
+        <a:font script="Cans" typeface="Euphemia"/>
+        <a:font script="Cher" typeface="Plantagenet Cherokee"/>
+        <a:font script="Yiii" typeface="Microsoft Yi Baiti"/>
+        <a:font script="Tibt" typeface="Microsoft Himalaya"/>
+        <a:font script="Thaa" typeface="MV Boli"/>
+        <a:font script="Deva" typeface="Mangal"/>
+        <a:font script="Telu" typeface="Gautami"/>
+        <a:font script="Taml" typeface="Latha"/>
+        <a:font script="Syrc" typeface="Estrangelo Edessa"/>
+        <a:font script="Orya" typeface="Kalinga"/>
+        <a:font script="Mlym" typeface="Kartika"/>
+        <a:font script="Laoo" typeface="DokChampa"/>
+        <a:font script="Sinh" typeface="Iskoola Pota"/>
+        <a:font script="Mong" typeface="Mongolian Baiti"/>
+        <a:font script="Viet" typeface="Arial"/>
+        <a:font script="Uigh" typeface="Microsoft Uighur"/>
+        <a:font script="Geor" typeface="Sylfaen"/>
+        <a:font script="Armn" typeface="Arial"/>
+        <a:font script="Bugi" typeface="Leelawadee UI"/>
+        <a:font script="Bopo" typeface="Microsoft JhengHei"/>
+        <a:font script="Java" typeface="Javanese Text"/>
+        <a:font script="Lisu" typeface="Segoe UI"/>
+        <a:font script="Mymr" typeface="Myanmar Text"/>
+        <a:font script="Nkoo" typeface="Ebrima"/>
+        <a:font script="Olck" typeface="Nirmala UI"/>
+        <a:font script="Osma" typeface="Ebrima"/>
+        <a:font script="Phag" typeface="Phagspa"/>
+        <a:font script="Syrn" typeface="Estrangelo Edessa"/>
+        <a:font script="Syrj" typeface="Estrangelo Edessa"/>
+        <a:font script="Syre" typeface="Estrangelo Edessa"/>
+        <a:font script="Sora" typeface="Nirmala UI"/>
+        <a:font script="Tale" typeface="Microsoft Tai Le"/>
+        <a:font script="Talu" typeface="Microsoft New Tai Lue"/>
+        <a:font script="Tfng" typeface="Ebrima"/>
+      </a:minorFont>
+    </a:fontScheme>
+    <a:fmtScheme name="Office">
+      <a:fillStyleLst>
+        <a:solidFill>
+          <a:schemeClr val="phClr"/>
+        </a:solidFill>
+        <a:gradFill rotWithShape="1">
+          <a:gsLst>
+            <a:gs pos="0">
+              <a:schemeClr val="phClr">
+                <a:lumMod val="110000"/>
+                <a:satMod val="105000"/>
+                <a:tint val="67000"/>
+              </a:schemeClr>
+            </a:gs>
+            <a:gs pos="50000">
+              <a:schemeClr val="phClr">
+                <a:lumMod val="105000"/>
+                <a:satMod val="103000"/>
+                <a:tint val="73000"/>
+              </a:schemeClr>
+            </a:gs>
+            <a:gs pos="100000">
+              <a:schemeClr val="phClr">
+                <a:lumMod val="105000"/>
+                <a:satMod val="109000"/>
+                <a:tint val="81000"/>
+              </a:schemeClr>
+            </a:gs>
+          </a:gsLst>
+          <a:lin ang="5400000" scaled="0"/>
+        </a:gradFill>
+        <a:gradFill rotWithShape="1">
+          <a:gsLst>
+            <a:gs pos="0">
+              <a:schemeClr val="phClr">
+                <a:satMod val="103000"/>
+                <a:lumMod val="102000"/>
+                <a:tint val="94000"/>
+              </a:schemeClr>
+            </a:gs>
+            <a:gs pos="50000">
+              <a:schemeClr val="phClr">
+                <a:satMod val="110000"/>
+                <a:lumMod val="100000"/>
+                <a:shade val="100000"/>
+              </a:schemeClr>
+            </a:gs>
+            <a:gs pos="100000">
+              <a:schemeClr val="phClr">
+                <a:lumMod val="99000"/>
+                <a:satMod val="120000"/>
+                <a:shade val="78000"/>
+              </a:schemeClr>
+            </a:gs>
+          </a:gsLst>
+          <a:lin ang="5400000" scaled="0"/>
+        </a:gradFill>
+      </a:fillStyleLst>
+      <a:lnStyleLst>
+        <a:ln w="6350" cap="flat" cmpd="sng" algn="ctr">
+          <a:solidFill>
+            <a:schemeClr val="phClr"/>
+          </a:solidFill>
+          <a:prstDash val="solid"/>
+          <a:miter lim="800000"/>
+        </a:ln>
+        <a:ln w="12700" cap="flat" cmpd="sng" algn="ctr">
+          <a:solidFill>
+            <a:schemeClr val="phClr"/>
+          </a:solidFill>
+          <a:prstDash val="solid"/>
+          <a:miter lim="800000"/>
+        </a:ln>
+        <a:ln w="19050" cap="flat" cmpd="sng" algn="ctr">
+          <a:solidFill>
+            <a:schemeClr val="phClr"/>
+          </a:solidFill>
+          <a:prstDash val="solid"/>
+          <a:miter lim="800000"/>
+        </a:ln>
+      </a:lnStyleLst>
+      <a:effectStyleLst>
+        <a:effectStyle>
+          <a:effectLst/>
+        </a:effectStyle>
+        <a:effectStyle>
+          <a:effectLst/>
+        </a:effectStyle>
+        <a:effectStyle>
+          <a:effectLst>
+            <a:outerShdw blurRad="57150" dist="19050" dir="5400000" algn="ctr" rotWithShape="0">
+              <a:srgbClr val="000000">
+                <a:alpha val="63000"/>
+              </a:srgbClr>
+            </a:outerShdw>
+          </a:effectLst>
+        </a:effectStyle>
+      </a:effectStyleLst>
+      <a:bgFillStyleLst>
+        <a:solidFill>
+          <a:schemeClr val="phClr"/>
+        </a:solidFill>
+        <a:solidFill>
+          <a:schemeClr val="phClr">
+            <a:tint val="95000"/>
+            <a:satMod val="170000"/>
+          </a:schemeClr>
+        </a:solidFill>
+        <a:gradFill rotWithShape="1">
+          <a:gsLst>
+            <a:gs pos="0">
+              <a:schemeClr val="phClr">
+                <a:tint val="93000"/>
+                <a:satMod val="150000"/>
+                <a:shade val="98000"/>
+                <a:lumMod val="102000"/>
+              </a:schemeClr>
+            </a:gs>
+            <a:gs pos="50000">
+              <a:schemeClr val="phClr">
+                <a:tint val="98000"/>
+                <a:satMod val="130000"/>
+                <a:shade val="90000"/>
+                <a:lumMod val="103000"/>
+              </a:schemeClr>
+            </a:gs>
+            <a:gs pos="100000">
+              <a:schemeClr val="phClr">
+                <a:shade val="63000"/>
+                <a:satMod val="120000"/>
+              </a:schemeClr>
+            </a:gs>
+          </a:gsLst>
+          <a:lin ang="5400000" scaled="0"/>
+        </a:gradFill>
+      </a:bgFillStyleLst>
+    </a:fmtScheme>
+  </a:themeElements>
+  <a:objectDefaults/>
+  <a:extraClrSchemeLst/>
+  <a:extLst>
+    <a:ext uri="{05A4C25C-085E-4340-85A3-A5531E510DB2}">
+      <thm15:themeFamily xmlns:thm15="http://schemas.microsoft.com/office/thememl/2012/main" name="Office Theme" id="{62F939B6-93AF-4DB8-9C6B-D6C7DFDC589F}" vid="{4A3C46E8-61CC-4603-A589-7422A47A8E4A}"/>
+    </a:ext>
+  </a:extLst>
+</a:theme>
 </file>
</xml_diff>